<commit_message>
KSA deck: add Instagram reel thumbnails to the social slide
Co-Authored-By: Claude Opus 5.5 <noreply@anthropic.com>
Claude-Session: https://claude.ai/code/session_01SNf1Edf2HMYqmZpheYf6i6
</commit_message>
<xml_diff>
--- a/emyaa-ceo-deck/output/vision-bank/eMYAA_KSA_Market_Discussion_-_v2.pptx
+++ b/emyaa-ceo-deck/output/vision-bank/eMYAA_KSA_Market_Discussion_-_v2.pptx
@@ -20265,7 +20265,7 @@
         <p:spPr>
           <a:xfrm>
             <a:off x="1234440" y="7818120"/>
-            <a:ext cx="16002000" cy="1554480"/>
+            <a:ext cx="9601200" cy="1554480"/>
           </a:xfrm>
           <a:prstGeom prst="rect">
             <a:avLst/>
@@ -20284,7 +20284,7 @@
               </a:spcAft>
             </a:pPr>
             <a:r>
-              <a:rPr sz="1750" b="1" i="0">
+              <a:rPr sz="1550" b="1" i="0">
                 <a:solidFill>
                   <a:srgbClr val="132257"/>
                 </a:solidFill>
@@ -20295,7 +20295,7 @@
               <a:t>Real people, not animation: </a:t>
             </a:r>
             <a:r>
-              <a:rPr sz="1750" b="0" i="0">
+              <a:rPr sz="1550" b="0" i="0">
                 <a:solidFill>
                   <a:srgbClr val="1F2A44"/>
                 </a:solidFill>
@@ -20313,7 +20313,7 @@
               </a:spcAft>
             </a:pPr>
             <a:r>
-              <a:rPr sz="1750" b="1" i="0">
+              <a:rPr sz="1550" b="1" i="0">
                 <a:solidFill>
                   <a:srgbClr val="132257"/>
                 </a:solidFill>
@@ -20324,7 +20324,7 @@
               <a:t>Paid boost on every key video: </a:t>
             </a:r>
             <a:r>
-              <a:rPr sz="1750" b="0" i="0">
+              <a:rPr sz="1550" b="0" i="0">
                 <a:solidFill>
                   <a:srgbClr val="1F2A44"/>
                 </a:solidFill>
@@ -20342,7 +20342,7 @@
               </a:spcAft>
             </a:pPr>
             <a:r>
-              <a:rPr sz="1750" b="1" i="0">
+              <a:rPr sz="1550" b="1" i="0">
                 <a:solidFill>
                   <a:srgbClr val="132257"/>
                 </a:solidFill>
@@ -20353,7 +20353,7 @@
               <a:t>Contests that ask for action: </a:t>
             </a:r>
             <a:r>
-              <a:rPr sz="1750" b="0" i="0">
+              <a:rPr sz="1550" b="0" i="0">
                 <a:solidFill>
                   <a:srgbClr val="1F2A44"/>
                 </a:solidFill>
@@ -20362,6 +20362,482 @@
                 <a:cs typeface="Exo 2"/>
               </a:rPr>
               <a:t>Mention &amp; Win turns views into follows and new accounts.</a:t>
+            </a:r>
+          </a:p>
+        </p:txBody>
+      </p:sp>
+      <p:pic>
+        <p:nvPicPr>
+          <p:cNvPr id="35" name="Picture 34" descr="tile9_musheera.png"/>
+          <p:cNvPicPr>
+            <a:picLocks noChangeAspect="1"/>
+          </p:cNvPicPr>
+          <p:nvPr/>
+        </p:nvPicPr>
+        <p:blipFill>
+          <a:blip r:embed="rId6"/>
+          <a:stretch>
+            <a:fillRect/>
+          </a:stretch>
+        </p:blipFill>
+        <p:spPr>
+          <a:xfrm>
+            <a:off x="10933661" y="7296912"/>
+            <a:ext cx="1527688" cy="1965960"/>
+          </a:xfrm>
+          <a:prstGeom prst="rect">
+            <a:avLst/>
+          </a:prstGeom>
+        </p:spPr>
+      </p:pic>
+      <p:sp>
+        <p:nvSpPr>
+          <p:cNvPr id="36" name="Rectangle 35"/>
+          <p:cNvSpPr/>
+          <p:nvPr/>
+        </p:nvSpPr>
+        <p:spPr>
+          <a:xfrm>
+            <a:off x="10933661" y="8759952"/>
+            <a:ext cx="1527688" cy="502920"/>
+          </a:xfrm>
+          <a:prstGeom prst="rect">
+            <a:avLst/>
+          </a:prstGeom>
+          <a:solidFill>
+            <a:srgbClr val="132257"/>
+          </a:solidFill>
+          <a:ln>
+            <a:noFill/>
+          </a:ln>
+          <a:effectLst/>
+        </p:spPr>
+        <p:style>
+          <a:lnRef idx="1">
+            <a:schemeClr val="accent1"/>
+          </a:lnRef>
+          <a:fillRef idx="3">
+            <a:schemeClr val="accent1"/>
+          </a:fillRef>
+          <a:effectRef idx="2">
+            <a:schemeClr val="accent1"/>
+          </a:effectRef>
+          <a:fontRef idx="minor">
+            <a:schemeClr val="lt1"/>
+          </a:fontRef>
+        </p:style>
+        <p:txBody>
+          <a:bodyPr rtlCol="0" anchor="ctr"/>
+          <a:lstStyle/>
+          <a:p>
+            <a:pPr algn="ctr"/>
+          </a:p>
+        </p:txBody>
+      </p:sp>
+      <p:sp>
+        <p:nvSpPr>
+          <p:cNvPr id="37" name="TextBox 36"/>
+          <p:cNvSpPr txBox="1"/>
+          <p:nvPr/>
+        </p:nvSpPr>
+        <p:spPr>
+          <a:xfrm>
+            <a:off x="11006813" y="8759952"/>
+            <a:ext cx="1381384" cy="502920"/>
+          </a:xfrm>
+          <a:prstGeom prst="rect">
+            <a:avLst/>
+          </a:prstGeom>
+          <a:noFill/>
+        </p:spPr>
+        <p:txBody>
+          <a:bodyPr wrap="square" anchor="ctr" lIns="0" rIns="0" tIns="0" bIns="0">
+            <a:spAutoFit/>
+          </a:bodyPr>
+          <a:lstStyle/>
+          <a:p>
+            <a:pPr algn="ctr"/>
+            <a:r>
+              <a:rPr sz="1050" b="1" i="0">
+                <a:solidFill>
+                  <a:srgbClr val="FFFFFF"/>
+                </a:solidFill>
+                <a:latin typeface="Exo 2 Bold"/>
+                <a:ea typeface="Exo 2 Bold"/>
+                <a:cs typeface="Exo 2 Bold"/>
+              </a:rPr>
+              <a:t>Musheera</a:t>
+            </a:r>
+          </a:p>
+          <a:p>
+            <a:pPr algn="ctr"/>
+            <a:r>
+              <a:rPr sz="1000" b="0" i="0">
+                <a:solidFill>
+                  <a:srgbClr val="D4AF37"/>
+                </a:solidFill>
+                <a:latin typeface="Exo 2"/>
+                <a:ea typeface="Exo 2"/>
+                <a:cs typeface="Exo 2"/>
+              </a:rPr>
+              <a:t>5.3M views</a:t>
+            </a:r>
+          </a:p>
+        </p:txBody>
+      </p:sp>
+      <p:pic>
+        <p:nvPicPr>
+          <p:cNvPr id="38" name="Picture 37" descr="tile9_ali.png"/>
+          <p:cNvPicPr>
+            <a:picLocks noChangeAspect="1"/>
+          </p:cNvPicPr>
+          <p:nvPr/>
+        </p:nvPicPr>
+        <p:blipFill>
+          <a:blip r:embed="rId7"/>
+          <a:stretch>
+            <a:fillRect/>
+          </a:stretch>
+        </p:blipFill>
+        <p:spPr>
+          <a:xfrm>
+            <a:off x="12571078" y="7296912"/>
+            <a:ext cx="1527688" cy="1965960"/>
+          </a:xfrm>
+          <a:prstGeom prst="rect">
+            <a:avLst/>
+          </a:prstGeom>
+        </p:spPr>
+      </p:pic>
+      <p:sp>
+        <p:nvSpPr>
+          <p:cNvPr id="39" name="Rectangle 38"/>
+          <p:cNvSpPr/>
+          <p:nvPr/>
+        </p:nvSpPr>
+        <p:spPr>
+          <a:xfrm>
+            <a:off x="12571078" y="8759952"/>
+            <a:ext cx="1527688" cy="502920"/>
+          </a:xfrm>
+          <a:prstGeom prst="rect">
+            <a:avLst/>
+          </a:prstGeom>
+          <a:solidFill>
+            <a:srgbClr val="132257"/>
+          </a:solidFill>
+          <a:ln>
+            <a:noFill/>
+          </a:ln>
+          <a:effectLst/>
+        </p:spPr>
+        <p:style>
+          <a:lnRef idx="1">
+            <a:schemeClr val="accent1"/>
+          </a:lnRef>
+          <a:fillRef idx="3">
+            <a:schemeClr val="accent1"/>
+          </a:fillRef>
+          <a:effectRef idx="2">
+            <a:schemeClr val="accent1"/>
+          </a:effectRef>
+          <a:fontRef idx="minor">
+            <a:schemeClr val="lt1"/>
+          </a:fontRef>
+        </p:style>
+        <p:txBody>
+          <a:bodyPr rtlCol="0" anchor="ctr"/>
+          <a:lstStyle/>
+          <a:p>
+            <a:pPr algn="ctr"/>
+          </a:p>
+        </p:txBody>
+      </p:sp>
+      <p:sp>
+        <p:nvSpPr>
+          <p:cNvPr id="40" name="TextBox 39"/>
+          <p:cNvSpPr txBox="1"/>
+          <p:nvPr/>
+        </p:nvSpPr>
+        <p:spPr>
+          <a:xfrm>
+            <a:off x="12644230" y="8759952"/>
+            <a:ext cx="1381384" cy="502920"/>
+          </a:xfrm>
+          <a:prstGeom prst="rect">
+            <a:avLst/>
+          </a:prstGeom>
+          <a:noFill/>
+        </p:spPr>
+        <p:txBody>
+          <a:bodyPr wrap="square" anchor="ctr" lIns="0" rIns="0" tIns="0" bIns="0">
+            <a:spAutoFit/>
+          </a:bodyPr>
+          <a:lstStyle/>
+          <a:p>
+            <a:pPr algn="ctr"/>
+            <a:r>
+              <a:rPr sz="1050" b="1" i="0">
+                <a:solidFill>
+                  <a:srgbClr val="FFFFFF"/>
+                </a:solidFill>
+                <a:latin typeface="Exo 2 Bold"/>
+                <a:ea typeface="Exo 2 Bold"/>
+                <a:cs typeface="Exo 2 Bold"/>
+              </a:rPr>
+              <a:t>Ali Sabeel</a:t>
+            </a:r>
+          </a:p>
+          <a:p>
+            <a:pPr algn="ctr"/>
+            <a:r>
+              <a:rPr sz="1000" b="0" i="0">
+                <a:solidFill>
+                  <a:srgbClr val="D4AF37"/>
+                </a:solidFill>
+                <a:latin typeface="Exo 2"/>
+                <a:ea typeface="Exo 2"/>
+                <a:cs typeface="Exo 2"/>
+              </a:rPr>
+              <a:t>1.3M views</a:t>
+            </a:r>
+          </a:p>
+        </p:txBody>
+      </p:sp>
+      <p:pic>
+        <p:nvPicPr>
+          <p:cNvPr id="41" name="Picture 40" descr="ksa_reel_mw.png"/>
+          <p:cNvPicPr>
+            <a:picLocks noChangeAspect="1"/>
+          </p:cNvPicPr>
+          <p:nvPr/>
+        </p:nvPicPr>
+        <p:blipFill>
+          <a:blip r:embed="rId8"/>
+          <a:stretch>
+            <a:fillRect/>
+          </a:stretch>
+        </p:blipFill>
+        <p:spPr>
+          <a:xfrm>
+            <a:off x="14208494" y="7296912"/>
+            <a:ext cx="1527688" cy="1965960"/>
+          </a:xfrm>
+          <a:prstGeom prst="rect">
+            <a:avLst/>
+          </a:prstGeom>
+        </p:spPr>
+      </p:pic>
+      <p:sp>
+        <p:nvSpPr>
+          <p:cNvPr id="42" name="Rectangle 41"/>
+          <p:cNvSpPr/>
+          <p:nvPr/>
+        </p:nvSpPr>
+        <p:spPr>
+          <a:xfrm>
+            <a:off x="14208494" y="8759952"/>
+            <a:ext cx="1527688" cy="502920"/>
+          </a:xfrm>
+          <a:prstGeom prst="rect">
+            <a:avLst/>
+          </a:prstGeom>
+          <a:solidFill>
+            <a:srgbClr val="132257"/>
+          </a:solidFill>
+          <a:ln>
+            <a:noFill/>
+          </a:ln>
+          <a:effectLst/>
+        </p:spPr>
+        <p:style>
+          <a:lnRef idx="1">
+            <a:schemeClr val="accent1"/>
+          </a:lnRef>
+          <a:fillRef idx="3">
+            <a:schemeClr val="accent1"/>
+          </a:fillRef>
+          <a:effectRef idx="2">
+            <a:schemeClr val="accent1"/>
+          </a:effectRef>
+          <a:fontRef idx="minor">
+            <a:schemeClr val="lt1"/>
+          </a:fontRef>
+        </p:style>
+        <p:txBody>
+          <a:bodyPr rtlCol="0" anchor="ctr"/>
+          <a:lstStyle/>
+          <a:p>
+            <a:pPr algn="ctr"/>
+          </a:p>
+        </p:txBody>
+      </p:sp>
+      <p:sp>
+        <p:nvSpPr>
+          <p:cNvPr id="43" name="TextBox 42"/>
+          <p:cNvSpPr txBox="1"/>
+          <p:nvPr/>
+        </p:nvSpPr>
+        <p:spPr>
+          <a:xfrm>
+            <a:off x="14281646" y="8759952"/>
+            <a:ext cx="1381384" cy="502920"/>
+          </a:xfrm>
+          <a:prstGeom prst="rect">
+            <a:avLst/>
+          </a:prstGeom>
+          <a:noFill/>
+        </p:spPr>
+        <p:txBody>
+          <a:bodyPr wrap="square" anchor="ctr" lIns="0" rIns="0" tIns="0" bIns="0">
+            <a:spAutoFit/>
+          </a:bodyPr>
+          <a:lstStyle/>
+          <a:p>
+            <a:pPr algn="ctr"/>
+            <a:r>
+              <a:rPr sz="1050" b="1" i="0">
+                <a:solidFill>
+                  <a:srgbClr val="FFFFFF"/>
+                </a:solidFill>
+                <a:latin typeface="Exo 2 Bold"/>
+                <a:ea typeface="Exo 2 Bold"/>
+                <a:cs typeface="Exo 2 Bold"/>
+              </a:rPr>
+              <a:t>Mention &amp; Win</a:t>
+            </a:r>
+          </a:p>
+          <a:p>
+            <a:pPr algn="ctr"/>
+            <a:r>
+              <a:rPr sz="1000" b="0" i="0">
+                <a:solidFill>
+                  <a:srgbClr val="D4AF37"/>
+                </a:solidFill>
+                <a:latin typeface="Exo 2"/>
+                <a:ea typeface="Exo 2"/>
+                <a:cs typeface="Exo 2"/>
+              </a:rPr>
+              <a:t>186K views</a:t>
+            </a:r>
+          </a:p>
+        </p:txBody>
+      </p:sp>
+      <p:pic>
+        <p:nvPicPr>
+          <p:cNvPr id="44" name="Picture 43" descr="tile9_abdulelah.png"/>
+          <p:cNvPicPr>
+            <a:picLocks noChangeAspect="1"/>
+          </p:cNvPicPr>
+          <p:nvPr/>
+        </p:nvPicPr>
+        <p:blipFill>
+          <a:blip r:embed="rId9"/>
+          <a:stretch>
+            <a:fillRect/>
+          </a:stretch>
+        </p:blipFill>
+        <p:spPr>
+          <a:xfrm>
+            <a:off x="15845911" y="7296912"/>
+            <a:ext cx="1527688" cy="1965960"/>
+          </a:xfrm>
+          <a:prstGeom prst="rect">
+            <a:avLst/>
+          </a:prstGeom>
+        </p:spPr>
+      </p:pic>
+      <p:sp>
+        <p:nvSpPr>
+          <p:cNvPr id="45" name="Rectangle 44"/>
+          <p:cNvSpPr/>
+          <p:nvPr/>
+        </p:nvSpPr>
+        <p:spPr>
+          <a:xfrm>
+            <a:off x="15845911" y="8759952"/>
+            <a:ext cx="1527688" cy="502920"/>
+          </a:xfrm>
+          <a:prstGeom prst="rect">
+            <a:avLst/>
+          </a:prstGeom>
+          <a:solidFill>
+            <a:srgbClr val="132257"/>
+          </a:solidFill>
+          <a:ln>
+            <a:noFill/>
+          </a:ln>
+          <a:effectLst/>
+        </p:spPr>
+        <p:style>
+          <a:lnRef idx="1">
+            <a:schemeClr val="accent1"/>
+          </a:lnRef>
+          <a:fillRef idx="3">
+            <a:schemeClr val="accent1"/>
+          </a:fillRef>
+          <a:effectRef idx="2">
+            <a:schemeClr val="accent1"/>
+          </a:effectRef>
+          <a:fontRef idx="minor">
+            <a:schemeClr val="lt1"/>
+          </a:fontRef>
+        </p:style>
+        <p:txBody>
+          <a:bodyPr rtlCol="0" anchor="ctr"/>
+          <a:lstStyle/>
+          <a:p>
+            <a:pPr algn="ctr"/>
+          </a:p>
+        </p:txBody>
+      </p:sp>
+      <p:sp>
+        <p:nvSpPr>
+          <p:cNvPr id="46" name="TextBox 45"/>
+          <p:cNvSpPr txBox="1"/>
+          <p:nvPr/>
+        </p:nvSpPr>
+        <p:spPr>
+          <a:xfrm>
+            <a:off x="15919063" y="8759952"/>
+            <a:ext cx="1381384" cy="502920"/>
+          </a:xfrm>
+          <a:prstGeom prst="rect">
+            <a:avLst/>
+          </a:prstGeom>
+          <a:noFill/>
+        </p:spPr>
+        <p:txBody>
+          <a:bodyPr wrap="square" anchor="ctr" lIns="0" rIns="0" tIns="0" bIns="0">
+            <a:spAutoFit/>
+          </a:bodyPr>
+          <a:lstStyle/>
+          <a:p>
+            <a:pPr algn="ctr"/>
+            <a:r>
+              <a:rPr sz="1050" b="1" i="0">
+                <a:solidFill>
+                  <a:srgbClr val="FFFFFF"/>
+                </a:solidFill>
+                <a:latin typeface="Exo 2 Bold"/>
+                <a:ea typeface="Exo 2 Bold"/>
+                <a:cs typeface="Exo 2 Bold"/>
+              </a:rPr>
+              <a:t>Abdulelah Al Harbi</a:t>
+            </a:r>
+          </a:p>
+          <a:p>
+            <a:pPr algn="ctr"/>
+            <a:r>
+              <a:rPr sz="1000" b="0" i="0">
+                <a:solidFill>
+                  <a:srgbClr val="D4AF37"/>
+                </a:solidFill>
+                <a:latin typeface="Exo 2"/>
+                <a:ea typeface="Exo 2"/>
+                <a:cs typeface="Exo 2"/>
+              </a:rPr>
+              <a:t>October</a:t>
             </a:r>
           </a:p>
         </p:txBody>

</xml_diff>

<commit_message>
KSA deck: add a marketing activity table since launch (slide 4)
Co-Authored-By: Claude Opus 5.5 <noreply@anthropic.com>
Claude-Session: https://claude.ai/code/session_01SNf1Edf2HMYqmZpheYf6i6
</commit_message>
<xml_diff>
--- a/emyaa-ceo-deck/output/vision-bank/eMYAA_KSA_Market_Discussion_-_v2.pptx
+++ b/emyaa-ceo-deck/output/vision-bank/eMYAA_KSA_Market_Discussion_-_v2.pptx
@@ -11,6 +11,7 @@
     <p:sldId id="256" r:id="rId6"/>
     <p:sldId id="257" r:id="rId7"/>
     <p:sldId id="263" r:id="rId25"/>
+    <p:sldId id="265" r:id="rId27"/>
     <p:sldId id="258" r:id="rId8"/>
     <p:sldId id="259" r:id="rId9"/>
     <p:sldId id="260" r:id="rId10"/>
@@ -686,6 +687,76 @@
             </a:r>
           </a:p>
         </p:txBody>
+      </p:sp>
+    </p:spTree>
+  </p:cSld>
+  <p:clrMapOvr>
+    <a:masterClrMapping/>
+  </p:clrMapOvr>
+</p:notes>
+</file>
+
+<file path=ppt/notesSlides/notesSlide10.xml><?xml version="1.0" encoding="utf-8"?>
+<p:notes xmlns:a="http://schemas.openxmlformats.org/drawingml/2006/main" xmlns:p="http://schemas.openxmlformats.org/presentationml/2006/main" xmlns:r="http://schemas.openxmlformats.org/officeDocument/2006/relationships">
+  <p:cSld>
+    <p:spTree>
+      <p:nvGrpSpPr>
+        <p:cNvPr id="1" name=""/>
+        <p:cNvGrpSpPr/>
+        <p:nvPr/>
+      </p:nvGrpSpPr>
+      <p:grpSpPr>
+        <a:xfrm>
+          <a:off x="0" y="0"/>
+          <a:ext cx="0" cy="0"/>
+          <a:chOff x="0" y="0"/>
+          <a:chExt cx="0" cy="0"/>
+        </a:xfrm>
+      </p:grpSpPr>
+      <p:sp>
+        <p:nvSpPr>
+          <p:cNvPr id="2" name="Slide Image Placeholder 1"/>
+          <p:cNvSpPr>
+            <a:spLocks noGrp="1"/>
+          </p:cNvSpPr>
+          <p:nvPr>
+            <p:ph type="sldImg" idx="2"/>
+          </p:nvPr>
+        </p:nvSpPr>
+        <p:spPr/>
+      </p:sp>
+      <p:sp>
+        <p:nvSpPr>
+          <p:cNvPr id="3" name="Notes Placeholder 2"/>
+          <p:cNvSpPr>
+            <a:spLocks noGrp="1"/>
+          </p:cNvSpPr>
+          <p:nvPr>
+            <p:ph type="body" idx="3" sz="quarter"/>
+          </p:nvPr>
+        </p:nvSpPr>
+        <p:spPr/>
+        <p:txBody>
+          <a:bodyPr/>
+          <a:lstStyle/>
+          <a:p>
+            <a:r>
+              <a:t>Sources: July 2026 monthly report (sponsored ads May to July: Long Form Launch, Astronaut, App Screens, GCC Relaunch, Mention &amp; Win pilot); Board update 17 Sep 2026 (marketing budget: USD 80,000 allocated, USD 34,482 spent 14 May to 6 Sep, influencer programme USD 9,037; USD 30,000 Google Ads and LinkedIn Sep to Dec); USD 5,000 campaign T&amp;Cs; GA4 1-28 Sep. GCC Relaunch results were not reported separately.</a:t>
+            </a:r>
+          </a:p>
+        </p:txBody>
+      </p:sp>
+      <p:sp>
+        <p:nvSpPr>
+          <p:cNvPr id="4" name="Slide Number Placeholder 3"/>
+          <p:cNvSpPr>
+            <a:spLocks noGrp="1"/>
+          </p:cNvSpPr>
+          <p:nvPr>
+            <p:ph type="sldNum" idx="5" sz="quarter"/>
+          </p:nvPr>
+        </p:nvSpPr>
+        <p:spPr/>
       </p:sp>
     </p:spTree>
   </p:cSld>
@@ -5434,6 +5505,4352 @@
 </p:sld>
 </file>
 
+<file path=ppt/slides/slide10.xml><?xml version="1.0" encoding="utf-8"?>
+<p:sld xmlns:a="http://schemas.openxmlformats.org/drawingml/2006/main" xmlns:p="http://schemas.openxmlformats.org/presentationml/2006/main" xmlns:r="http://schemas.openxmlformats.org/officeDocument/2006/relationships">
+  <p:cSld>
+    <p:spTree>
+      <p:nvGrpSpPr>
+        <p:cNvPr id="1" name=""/>
+        <p:cNvGrpSpPr/>
+        <p:nvPr/>
+      </p:nvGrpSpPr>
+      <p:grpSpPr/>
+      <p:grpSp>
+        <p:nvGrpSpPr>
+          <p:cNvPr name="Group 2" id="2"/>
+          <p:cNvGrpSpPr/>
+          <p:nvPr/>
+        </p:nvGrpSpPr>
+        <p:grpSpPr>
+          <a:xfrm rot="0">
+            <a:off x="0" y="0"/>
+            <a:ext cx="18287543" cy="1947672"/>
+            <a:chOff x="0" y="0"/>
+            <a:chExt cx="24383390" cy="2596896"/>
+          </a:xfrm>
+        </p:grpSpPr>
+        <p:sp>
+          <p:nvSpPr>
+            <p:cNvPr name="Freeform 3" id="3" descr="/home/user/HatemIsa_202508993_IT9002_NLP_Project/emyaa-ceo-deck/working/charts/board_header.png"/>
+            <p:cNvSpPr/>
+            <p:nvPr/>
+          </p:nvSpPr>
+          <p:spPr>
+            <a:xfrm flipH="false" flipV="false" rot="0">
+              <a:off x="0" y="0"/>
+              <a:ext cx="24383364" cy="2596896"/>
+            </a:xfrm>
+            <a:custGeom>
+              <a:avLst/>
+              <a:gdLst/>
+              <a:ahLst/>
+              <a:cxnLst/>
+              <a:rect r="r" b="b" t="t" l="l"/>
+              <a:pathLst>
+                <a:path h="2596896" w="24383364">
+                  <a:moveTo>
+                    <a:pt x="0" y="0"/>
+                  </a:moveTo>
+                  <a:lnTo>
+                    <a:pt x="24383364" y="0"/>
+                  </a:lnTo>
+                  <a:lnTo>
+                    <a:pt x="24383364" y="2596896"/>
+                  </a:lnTo>
+                  <a:lnTo>
+                    <a:pt x="0" y="2596896"/>
+                  </a:lnTo>
+                  <a:lnTo>
+                    <a:pt x="0" y="0"/>
+                  </a:lnTo>
+                  <a:close/>
+                </a:path>
+              </a:pathLst>
+            </a:custGeom>
+            <a:blipFill>
+              <a:blip r:embed="rId2"/>
+              <a:stretch>
+                <a:fillRect l="0" t="-1172" r="0" b="-1172"/>
+              </a:stretch>
+            </a:blipFill>
+          </p:spPr>
+        </p:sp>
+      </p:grpSp>
+      <p:grpSp>
+        <p:nvGrpSpPr>
+          <p:cNvPr name="Group 4" id="4"/>
+          <p:cNvGrpSpPr/>
+          <p:nvPr/>
+        </p:nvGrpSpPr>
+        <p:grpSpPr>
+          <a:xfrm rot="0">
+            <a:off x="-9525" y="1938147"/>
+            <a:ext cx="18306593" cy="60198"/>
+            <a:chOff x="0" y="0"/>
+            <a:chExt cx="24408790" cy="80264"/>
+          </a:xfrm>
+        </p:grpSpPr>
+        <p:sp>
+          <p:nvSpPr>
+            <p:cNvPr name="Freeform 5" id="5"/>
+            <p:cNvSpPr/>
+            <p:nvPr/>
+          </p:nvSpPr>
+          <p:spPr>
+            <a:xfrm flipH="false" flipV="false" rot="0">
+              <a:off x="0" y="0"/>
+              <a:ext cx="24408764" cy="80264"/>
+            </a:xfrm>
+            <a:custGeom>
+              <a:avLst/>
+              <a:gdLst/>
+              <a:ahLst/>
+              <a:cxnLst/>
+              <a:rect r="r" b="b" t="t" l="l"/>
+              <a:pathLst>
+                <a:path h="80264" w="24408764">
+                  <a:moveTo>
+                    <a:pt x="0" y="0"/>
+                  </a:moveTo>
+                  <a:lnTo>
+                    <a:pt x="24408764" y="0"/>
+                  </a:lnTo>
+                  <a:lnTo>
+                    <a:pt x="24408764" y="80264"/>
+                  </a:lnTo>
+                  <a:lnTo>
+                    <a:pt x="0" y="80264"/>
+                  </a:lnTo>
+                  <a:close/>
+                </a:path>
+              </a:pathLst>
+            </a:custGeom>
+            <a:solidFill>
+              <a:srgbClr val="D4AF37"/>
+            </a:solidFill>
+            <a:ln w="19050" cap="sq">
+              <a:solidFill>
+                <a:srgbClr val="D4AF37"/>
+              </a:solidFill>
+              <a:prstDash val="solid"/>
+              <a:miter/>
+            </a:ln>
+          </p:spPr>
+        </p:sp>
+      </p:grpSp>
+      <p:sp>
+        <p:nvSpPr>
+          <p:cNvPr name="TextBox 6" id="6"/>
+          <p:cNvSpPr txBox="true"/>
+          <p:nvPr/>
+        </p:nvSpPr>
+        <p:spPr>
+          <a:xfrm rot="0">
+            <a:off x="850392" y="401955"/>
+            <a:ext cx="13716000" cy="311277"/>
+          </a:xfrm>
+          <a:prstGeom prst="rect">
+            <a:avLst/>
+          </a:prstGeom>
+        </p:spPr>
+        <p:txBody>
+          <a:bodyPr anchor="t" rtlCol="false" tIns="0" lIns="0" bIns="0" rIns="0">
+            <a:spAutoFit/>
+          </a:bodyPr>
+          <a:lstStyle/>
+          <a:p>
+            <a:pPr algn="l">
+              <a:lnSpc>
+                <a:spcPts val="1709"/>
+              </a:lnSpc>
+            </a:pPr>
+            <a:r>
+              <a:rPr lang="en-US" b="true" sz="1425" spc="299">
+                <a:solidFill>
+                  <a:srgbClr val="D4AF37"/>
+                </a:solidFill>
+                <a:latin typeface="Exo 2 Bold"/>
+                <a:ea typeface="Exo 2 Bold"/>
+                <a:cs typeface="Exo 2 Bold"/>
+                <a:sym typeface="Exo 2 Bold"/>
+              </a:rPr>
+              <a:t>WHAT WE HAVE DONE SO FAR</a:t>
+            </a:r>
+          </a:p>
+        </p:txBody>
+      </p:sp>
+      <p:grpSp>
+        <p:nvGrpSpPr>
+          <p:cNvPr name="Group 7" id="7"/>
+          <p:cNvGrpSpPr/>
+          <p:nvPr/>
+        </p:nvGrpSpPr>
+        <p:grpSpPr>
+          <a:xfrm rot="0">
+            <a:off x="850392" y="713232"/>
+            <a:ext cx="14127480" cy="1124712"/>
+            <a:chOff x="0" y="0"/>
+            <a:chExt cx="18836640" cy="1499616"/>
+          </a:xfrm>
+        </p:grpSpPr>
+        <p:sp>
+          <p:nvSpPr>
+            <p:cNvPr name="Freeform 8" id="8"/>
+            <p:cNvSpPr/>
+            <p:nvPr/>
+          </p:nvSpPr>
+          <p:spPr>
+            <a:xfrm flipH="false" flipV="false" rot="0">
+              <a:off x="0" y="0"/>
+              <a:ext cx="18836639" cy="1499616"/>
+            </a:xfrm>
+            <a:custGeom>
+              <a:avLst/>
+              <a:gdLst/>
+              <a:ahLst/>
+              <a:cxnLst/>
+              <a:rect r="r" b="b" t="t" l="l"/>
+              <a:pathLst>
+                <a:path h="1499616" w="18836639">
+                  <a:moveTo>
+                    <a:pt x="0" y="0"/>
+                  </a:moveTo>
+                  <a:lnTo>
+                    <a:pt x="18836639" y="0"/>
+                  </a:lnTo>
+                  <a:lnTo>
+                    <a:pt x="18836639" y="1499616"/>
+                  </a:lnTo>
+                  <a:lnTo>
+                    <a:pt x="0" y="1499616"/>
+                  </a:lnTo>
+                  <a:close/>
+                </a:path>
+              </a:pathLst>
+            </a:custGeom>
+            <a:blipFill>
+              <a:blip r:embed="rId3">
+                <a:alphaModFix amt="0"/>
+              </a:blip>
+              <a:stretch>
+                <a:fillRect l="0" t="-194751" r="0" b="-194751"/>
+              </a:stretch>
+            </a:blipFill>
+          </p:spPr>
+        </p:sp>
+        <p:sp>
+          <p:nvSpPr>
+            <p:cNvPr name="TextBox 9" id="9"/>
+            <p:cNvSpPr txBox="true"/>
+            <p:nvPr/>
+          </p:nvSpPr>
+          <p:spPr>
+            <a:xfrm>
+              <a:off x="0" y="-9525"/>
+              <a:ext cx="18836640" cy="1509141"/>
+            </a:xfrm>
+            <a:prstGeom prst="rect">
+              <a:avLst/>
+            </a:prstGeom>
+          </p:spPr>
+          <p:txBody>
+            <a:bodyPr anchor="ctr" rtlCol="false" tIns="0" lIns="0" bIns="0" rIns="0"/>
+            <a:lstStyle/>
+            <a:p>
+              <a:pPr algn="l">
+                <a:lnSpc>
+                  <a:spcPts val="3960"/>
+                </a:lnSpc>
+              </a:pPr>
+              <a:r>
+                <a:rPr lang="en-US" sz="3300" b="true">
+                  <a:solidFill>
+                    <a:srgbClr val="FFFFFF"/>
+                  </a:solidFill>
+                  <a:latin typeface="Exo 2 Bold"/>
+                  <a:ea typeface="Exo 2 Bold"/>
+                  <a:cs typeface="Exo 2 Bold"/>
+                  <a:sym typeface="Exo 2 Bold"/>
+                </a:rPr>
+                <a:t>Marketing Activity Since Launch, May to October 2026</a:t>
+              </a:r>
+            </a:p>
+          </p:txBody>
+        </p:sp>
+      </p:grpSp>
+      <p:grpSp>
+        <p:nvGrpSpPr>
+          <p:cNvPr name="Group 10" id="10"/>
+          <p:cNvGrpSpPr/>
+          <p:nvPr/>
+        </p:nvGrpSpPr>
+        <p:grpSpPr>
+          <a:xfrm rot="0">
+            <a:off x="15457932" y="685800"/>
+            <a:ext cx="1988820" cy="576072"/>
+            <a:chOff x="0" y="0"/>
+            <a:chExt cx="2651760" cy="768096"/>
+          </a:xfrm>
+        </p:grpSpPr>
+        <p:sp>
+          <p:nvSpPr>
+            <p:cNvPr name="Freeform 11" id="11" descr="/home/user/HatemIsa_202508993_IT9002_NLP_Project/emyaa-ceo-deck/working/charts/ajyad_white.png"/>
+            <p:cNvSpPr/>
+            <p:nvPr/>
+          </p:nvSpPr>
+          <p:spPr>
+            <a:xfrm flipH="false" flipV="false" rot="0">
+              <a:off x="0" y="0"/>
+              <a:ext cx="2651760" cy="768096"/>
+            </a:xfrm>
+            <a:custGeom>
+              <a:avLst/>
+              <a:gdLst/>
+              <a:ahLst/>
+              <a:cxnLst/>
+              <a:rect r="r" b="b" t="t" l="l"/>
+              <a:pathLst>
+                <a:path h="768096" w="2651760">
+                  <a:moveTo>
+                    <a:pt x="0" y="0"/>
+                  </a:moveTo>
+                  <a:lnTo>
+                    <a:pt x="2651760" y="0"/>
+                  </a:lnTo>
+                  <a:lnTo>
+                    <a:pt x="2651760" y="768096"/>
+                  </a:lnTo>
+                  <a:lnTo>
+                    <a:pt x="0" y="768096"/>
+                  </a:lnTo>
+                  <a:lnTo>
+                    <a:pt x="0" y="0"/>
+                  </a:lnTo>
+                  <a:close/>
+                </a:path>
+              </a:pathLst>
+            </a:custGeom>
+            <a:blipFill>
+              <a:blip r:embed="rId4"/>
+              <a:stretch>
+                <a:fillRect l="0" t="-26" r="0" b="-26"/>
+              </a:stretch>
+            </a:blipFill>
+          </p:spPr>
+        </p:sp>
+      </p:grpSp>
+      <p:sp>
+        <p:nvSpPr>
+          <p:cNvPr name="TextBox 12" id="12"/>
+          <p:cNvSpPr txBox="true"/>
+          <p:nvPr/>
+        </p:nvSpPr>
+        <p:spPr>
+          <a:xfrm rot="0">
+            <a:off x="850392" y="9728835"/>
+            <a:ext cx="8229600" cy="311277"/>
+          </a:xfrm>
+          <a:prstGeom prst="rect">
+            <a:avLst/>
+          </a:prstGeom>
+        </p:spPr>
+        <p:txBody>
+          <a:bodyPr anchor="t" rtlCol="false" tIns="0" lIns="0" bIns="0" rIns="0">
+            <a:spAutoFit/>
+          </a:bodyPr>
+          <a:lstStyle/>
+          <a:p>
+            <a:pPr algn="l">
+              <a:lnSpc>
+                <a:spcPts val="1439"/>
+              </a:lnSpc>
+            </a:pPr>
+            <a:r>
+              <a:rPr lang="en-US" sz="1200">
+                <a:solidFill>
+                  <a:srgbClr val="8A93A8"/>
+                </a:solidFill>
+                <a:latin typeface="Exo 2"/>
+                <a:ea typeface="Exo 2"/>
+                <a:cs typeface="Exo 2"/>
+                <a:sym typeface="Exo 2"/>
+              </a:rPr>
+              <a:t>eMYAA Trading Platform  |  Saudi Market Plan</a:t>
+            </a:r>
+          </a:p>
+        </p:txBody>
+      </p:sp>
+      <p:sp>
+        <p:nvSpPr>
+          <p:cNvPr name="TextBox 13" id="13"/>
+          <p:cNvSpPr txBox="true"/>
+          <p:nvPr/>
+        </p:nvSpPr>
+        <p:spPr>
+          <a:xfrm rot="0">
+            <a:off x="14703552" y="9728835"/>
+            <a:ext cx="685800" cy="190500"/>
+          </a:xfrm>
+          <a:prstGeom prst="rect">
+            <a:avLst/>
+          </a:prstGeom>
+        </p:spPr>
+        <p:txBody>
+          <a:bodyPr anchor="t" rtlCol="false" tIns="0" lIns="0" bIns="0" rIns="0">
+            <a:spAutoFit/>
+          </a:bodyPr>
+          <a:lstStyle/>
+          <a:p>
+            <a:pPr algn="r">
+              <a:lnSpc>
+                <a:spcPts val="1439"/>
+              </a:lnSpc>
+            </a:pPr>
+            <a:r>
+              <a:rPr lang="en-US" sz="1200">
+                <a:solidFill>
+                  <a:srgbClr val="8A93A8"/>
+                </a:solidFill>
+                <a:latin typeface="Exo 2"/>
+                <a:ea typeface="Exo 2"/>
+                <a:cs typeface="Exo 2"/>
+                <a:sym typeface="Exo 2"/>
+              </a:rPr>
+              <a:t>4</a:t>
+            </a:r>
+          </a:p>
+        </p:txBody>
+      </p:sp>
+      <p:grpSp>
+        <p:nvGrpSpPr>
+          <p:cNvPr name="Group 14" id="14"/>
+          <p:cNvGrpSpPr/>
+          <p:nvPr/>
+        </p:nvGrpSpPr>
+        <p:grpSpPr>
+          <a:xfrm rot="0">
+            <a:off x="15910560" y="9491472"/>
+            <a:ext cx="1536192" cy="548640"/>
+            <a:chOff x="0" y="0"/>
+            <a:chExt cx="2048256" cy="731520"/>
+          </a:xfrm>
+        </p:grpSpPr>
+        <p:sp>
+          <p:nvSpPr>
+            <p:cNvPr name="Freeform 15" id="15" descr="/home/user/HatemIsa_202508993_IT9002_NLP_Project/emyaa-ceo-deck/working/charts/emyaa_navy.png"/>
+            <p:cNvSpPr/>
+            <p:nvPr/>
+          </p:nvSpPr>
+          <p:spPr>
+            <a:xfrm flipH="false" flipV="false" rot="0">
+              <a:off x="0" y="0"/>
+              <a:ext cx="2048256" cy="731520"/>
+            </a:xfrm>
+            <a:custGeom>
+              <a:avLst/>
+              <a:gdLst/>
+              <a:ahLst/>
+              <a:cxnLst/>
+              <a:rect r="r" b="b" t="t" l="l"/>
+              <a:pathLst>
+                <a:path h="731520" w="2048256">
+                  <a:moveTo>
+                    <a:pt x="0" y="0"/>
+                  </a:moveTo>
+                  <a:lnTo>
+                    <a:pt x="2048256" y="0"/>
+                  </a:lnTo>
+                  <a:lnTo>
+                    <a:pt x="2048256" y="731520"/>
+                  </a:lnTo>
+                  <a:lnTo>
+                    <a:pt x="0" y="731520"/>
+                  </a:lnTo>
+                  <a:lnTo>
+                    <a:pt x="0" y="0"/>
+                  </a:lnTo>
+                  <a:close/>
+                </a:path>
+              </a:pathLst>
+            </a:custGeom>
+            <a:blipFill>
+              <a:blip r:embed="rId5"/>
+              <a:stretch>
+                <a:fillRect l="-301" t="0" r="-301" b="0"/>
+              </a:stretch>
+            </a:blipFill>
+          </p:spPr>
+        </p:sp>
+      </p:grpSp>
+      <p:sp>
+        <p:nvSpPr>
+          <p:cNvPr id="16" name="Rectangle 15"/>
+          <p:cNvSpPr/>
+          <p:nvPr/>
+        </p:nvSpPr>
+        <p:spPr>
+          <a:xfrm>
+            <a:off x="841248" y="2331720"/>
+            <a:ext cx="3291840" cy="566928"/>
+          </a:xfrm>
+          <a:prstGeom prst="rect">
+            <a:avLst/>
+          </a:prstGeom>
+          <a:solidFill>
+            <a:srgbClr val="132257"/>
+          </a:solidFill>
+          <a:ln>
+            <a:noFill/>
+          </a:ln>
+          <a:effectLst/>
+        </p:spPr>
+        <p:style>
+          <a:lnRef idx="1">
+            <a:schemeClr val="accent1"/>
+          </a:lnRef>
+          <a:fillRef idx="3">
+            <a:schemeClr val="accent1"/>
+          </a:fillRef>
+          <a:effectRef idx="2">
+            <a:schemeClr val="accent1"/>
+          </a:effectRef>
+          <a:fontRef idx="minor">
+            <a:schemeClr val="lt1"/>
+          </a:fontRef>
+        </p:style>
+        <p:txBody>
+          <a:bodyPr rtlCol="0" anchor="ctr"/>
+          <a:lstStyle/>
+          <a:p>
+            <a:pPr algn="ctr"/>
+          </a:p>
+        </p:txBody>
+      </p:sp>
+      <p:sp>
+        <p:nvSpPr>
+          <p:cNvPr id="17" name="TextBox 16"/>
+          <p:cNvSpPr txBox="1"/>
+          <p:nvPr/>
+        </p:nvSpPr>
+        <p:spPr>
+          <a:xfrm>
+            <a:off x="1005840" y="2331720"/>
+            <a:ext cx="3017520" cy="566928"/>
+          </a:xfrm>
+          <a:prstGeom prst="rect">
+            <a:avLst/>
+          </a:prstGeom>
+          <a:noFill/>
+        </p:spPr>
+        <p:txBody>
+          <a:bodyPr wrap="square" anchor="ctr" lIns="0" rIns="0" tIns="0" bIns="0">
+            <a:spAutoFit/>
+          </a:bodyPr>
+          <a:lstStyle/>
+          <a:p>
+            <a:pPr algn="l"/>
+            <a:r>
+              <a:rPr sz="1500" b="1" i="0">
+                <a:solidFill>
+                  <a:srgbClr val="FFFFFF"/>
+                </a:solidFill>
+                <a:latin typeface="Exo 2 Bold"/>
+                <a:ea typeface="Exo 2 Bold"/>
+                <a:cs typeface="Exo 2 Bold"/>
+              </a:rPr>
+              <a:t>Campaign</a:t>
+            </a:r>
+          </a:p>
+        </p:txBody>
+      </p:sp>
+      <p:sp>
+        <p:nvSpPr>
+          <p:cNvPr id="18" name="Rectangle 17"/>
+          <p:cNvSpPr/>
+          <p:nvPr/>
+        </p:nvSpPr>
+        <p:spPr>
+          <a:xfrm>
+            <a:off x="4133088" y="2331720"/>
+            <a:ext cx="2743200" cy="566928"/>
+          </a:xfrm>
+          <a:prstGeom prst="rect">
+            <a:avLst/>
+          </a:prstGeom>
+          <a:solidFill>
+            <a:srgbClr val="132257"/>
+          </a:solidFill>
+          <a:ln>
+            <a:noFill/>
+          </a:ln>
+          <a:effectLst/>
+        </p:spPr>
+        <p:style>
+          <a:lnRef idx="1">
+            <a:schemeClr val="accent1"/>
+          </a:lnRef>
+          <a:fillRef idx="3">
+            <a:schemeClr val="accent1"/>
+          </a:fillRef>
+          <a:effectRef idx="2">
+            <a:schemeClr val="accent1"/>
+          </a:effectRef>
+          <a:fontRef idx="minor">
+            <a:schemeClr val="lt1"/>
+          </a:fontRef>
+        </p:style>
+        <p:txBody>
+          <a:bodyPr rtlCol="0" anchor="ctr"/>
+          <a:lstStyle/>
+          <a:p>
+            <a:pPr algn="ctr"/>
+          </a:p>
+        </p:txBody>
+      </p:sp>
+      <p:sp>
+        <p:nvSpPr>
+          <p:cNvPr id="19" name="TextBox 18"/>
+          <p:cNvSpPr txBox="1"/>
+          <p:nvPr/>
+        </p:nvSpPr>
+        <p:spPr>
+          <a:xfrm>
+            <a:off x="4297680" y="2331720"/>
+            <a:ext cx="2468880" cy="566928"/>
+          </a:xfrm>
+          <a:prstGeom prst="rect">
+            <a:avLst/>
+          </a:prstGeom>
+          <a:noFill/>
+        </p:spPr>
+        <p:txBody>
+          <a:bodyPr wrap="square" anchor="ctr" lIns="0" rIns="0" tIns="0" bIns="0">
+            <a:spAutoFit/>
+          </a:bodyPr>
+          <a:lstStyle/>
+          <a:p>
+            <a:pPr algn="l"/>
+            <a:r>
+              <a:rPr sz="1500" b="1" i="0">
+                <a:solidFill>
+                  <a:srgbClr val="FFFFFF"/>
+                </a:solidFill>
+                <a:latin typeface="Exo 2 Bold"/>
+                <a:ea typeface="Exo 2 Bold"/>
+                <a:cs typeface="Exo 2 Bold"/>
+              </a:rPr>
+              <a:t>Platform</a:t>
+            </a:r>
+          </a:p>
+        </p:txBody>
+      </p:sp>
+      <p:sp>
+        <p:nvSpPr>
+          <p:cNvPr id="20" name="Rectangle 19"/>
+          <p:cNvSpPr/>
+          <p:nvPr/>
+        </p:nvSpPr>
+        <p:spPr>
+          <a:xfrm>
+            <a:off x="6876288" y="2331720"/>
+            <a:ext cx="2377440" cy="566928"/>
+          </a:xfrm>
+          <a:prstGeom prst="rect">
+            <a:avLst/>
+          </a:prstGeom>
+          <a:solidFill>
+            <a:srgbClr val="132257"/>
+          </a:solidFill>
+          <a:ln>
+            <a:noFill/>
+          </a:ln>
+          <a:effectLst/>
+        </p:spPr>
+        <p:style>
+          <a:lnRef idx="1">
+            <a:schemeClr val="accent1"/>
+          </a:lnRef>
+          <a:fillRef idx="3">
+            <a:schemeClr val="accent1"/>
+          </a:fillRef>
+          <a:effectRef idx="2">
+            <a:schemeClr val="accent1"/>
+          </a:effectRef>
+          <a:fontRef idx="minor">
+            <a:schemeClr val="lt1"/>
+          </a:fontRef>
+        </p:style>
+        <p:txBody>
+          <a:bodyPr rtlCol="0" anchor="ctr"/>
+          <a:lstStyle/>
+          <a:p>
+            <a:pPr algn="ctr"/>
+          </a:p>
+        </p:txBody>
+      </p:sp>
+      <p:sp>
+        <p:nvSpPr>
+          <p:cNvPr id="21" name="TextBox 20"/>
+          <p:cNvSpPr txBox="1"/>
+          <p:nvPr/>
+        </p:nvSpPr>
+        <p:spPr>
+          <a:xfrm>
+            <a:off x="7040880" y="2331720"/>
+            <a:ext cx="2103120" cy="566928"/>
+          </a:xfrm>
+          <a:prstGeom prst="rect">
+            <a:avLst/>
+          </a:prstGeom>
+          <a:noFill/>
+        </p:spPr>
+        <p:txBody>
+          <a:bodyPr wrap="square" anchor="ctr" lIns="0" rIns="0" tIns="0" bIns="0">
+            <a:spAutoFit/>
+          </a:bodyPr>
+          <a:lstStyle/>
+          <a:p>
+            <a:pPr algn="l"/>
+            <a:r>
+              <a:rPr sz="1500" b="1" i="0">
+                <a:solidFill>
+                  <a:srgbClr val="FFFFFF"/>
+                </a:solidFill>
+                <a:latin typeface="Exo 2 Bold"/>
+                <a:ea typeface="Exo 2 Bold"/>
+                <a:cs typeface="Exo 2 Bold"/>
+              </a:rPr>
+              <a:t>When</a:t>
+            </a:r>
+          </a:p>
+        </p:txBody>
+      </p:sp>
+      <p:sp>
+        <p:nvSpPr>
+          <p:cNvPr id="22" name="Rectangle 21"/>
+          <p:cNvSpPr/>
+          <p:nvPr/>
+        </p:nvSpPr>
+        <p:spPr>
+          <a:xfrm>
+            <a:off x="9253728" y="2331720"/>
+            <a:ext cx="2148840" cy="566928"/>
+          </a:xfrm>
+          <a:prstGeom prst="rect">
+            <a:avLst/>
+          </a:prstGeom>
+          <a:solidFill>
+            <a:srgbClr val="132257"/>
+          </a:solidFill>
+          <a:ln>
+            <a:noFill/>
+          </a:ln>
+          <a:effectLst/>
+        </p:spPr>
+        <p:style>
+          <a:lnRef idx="1">
+            <a:schemeClr val="accent1"/>
+          </a:lnRef>
+          <a:fillRef idx="3">
+            <a:schemeClr val="accent1"/>
+          </a:fillRef>
+          <a:effectRef idx="2">
+            <a:schemeClr val="accent1"/>
+          </a:effectRef>
+          <a:fontRef idx="minor">
+            <a:schemeClr val="lt1"/>
+          </a:fontRef>
+        </p:style>
+        <p:txBody>
+          <a:bodyPr rtlCol="0" anchor="ctr"/>
+          <a:lstStyle/>
+          <a:p>
+            <a:pPr algn="ctr"/>
+          </a:p>
+        </p:txBody>
+      </p:sp>
+      <p:sp>
+        <p:nvSpPr>
+          <p:cNvPr id="23" name="TextBox 22"/>
+          <p:cNvSpPr txBox="1"/>
+          <p:nvPr/>
+        </p:nvSpPr>
+        <p:spPr>
+          <a:xfrm>
+            <a:off x="9418320" y="2331720"/>
+            <a:ext cx="1874520" cy="566928"/>
+          </a:xfrm>
+          <a:prstGeom prst="rect">
+            <a:avLst/>
+          </a:prstGeom>
+          <a:noFill/>
+        </p:spPr>
+        <p:txBody>
+          <a:bodyPr wrap="square" anchor="ctr" lIns="0" rIns="0" tIns="0" bIns="0">
+            <a:spAutoFit/>
+          </a:bodyPr>
+          <a:lstStyle/>
+          <a:p>
+            <a:pPr algn="l"/>
+            <a:r>
+              <a:rPr sz="1500" b="1" i="0">
+                <a:solidFill>
+                  <a:srgbClr val="FFFFFF"/>
+                </a:solidFill>
+                <a:latin typeface="Exo 2 Bold"/>
+                <a:ea typeface="Exo 2 Bold"/>
+                <a:cs typeface="Exo 2 Bold"/>
+              </a:rPr>
+              <a:t>Spend (USD)</a:t>
+            </a:r>
+          </a:p>
+        </p:txBody>
+      </p:sp>
+      <p:sp>
+        <p:nvSpPr>
+          <p:cNvPr id="24" name="Rectangle 23"/>
+          <p:cNvSpPr/>
+          <p:nvPr/>
+        </p:nvSpPr>
+        <p:spPr>
+          <a:xfrm>
+            <a:off x="11402568" y="2331720"/>
+            <a:ext cx="6053328" cy="566928"/>
+          </a:xfrm>
+          <a:prstGeom prst="rect">
+            <a:avLst/>
+          </a:prstGeom>
+          <a:solidFill>
+            <a:srgbClr val="132257"/>
+          </a:solidFill>
+          <a:ln>
+            <a:noFill/>
+          </a:ln>
+          <a:effectLst/>
+        </p:spPr>
+        <p:style>
+          <a:lnRef idx="1">
+            <a:schemeClr val="accent1"/>
+          </a:lnRef>
+          <a:fillRef idx="3">
+            <a:schemeClr val="accent1"/>
+          </a:fillRef>
+          <a:effectRef idx="2">
+            <a:schemeClr val="accent1"/>
+          </a:effectRef>
+          <a:fontRef idx="minor">
+            <a:schemeClr val="lt1"/>
+          </a:fontRef>
+        </p:style>
+        <p:txBody>
+          <a:bodyPr rtlCol="0" anchor="ctr"/>
+          <a:lstStyle/>
+          <a:p>
+            <a:pPr algn="ctr"/>
+          </a:p>
+        </p:txBody>
+      </p:sp>
+      <p:sp>
+        <p:nvSpPr>
+          <p:cNvPr id="25" name="TextBox 24"/>
+          <p:cNvSpPr txBox="1"/>
+          <p:nvPr/>
+        </p:nvSpPr>
+        <p:spPr>
+          <a:xfrm>
+            <a:off x="11567160" y="2331720"/>
+            <a:ext cx="5779008" cy="566928"/>
+          </a:xfrm>
+          <a:prstGeom prst="rect">
+            <a:avLst/>
+          </a:prstGeom>
+          <a:noFill/>
+        </p:spPr>
+        <p:txBody>
+          <a:bodyPr wrap="square" anchor="ctr" lIns="0" rIns="0" tIns="0" bIns="0">
+            <a:spAutoFit/>
+          </a:bodyPr>
+          <a:lstStyle/>
+          <a:p>
+            <a:pPr algn="l"/>
+            <a:r>
+              <a:rPr sz="1500" b="1" i="0">
+                <a:solidFill>
+                  <a:srgbClr val="FFFFFF"/>
+                </a:solidFill>
+                <a:latin typeface="Exo 2 Bold"/>
+                <a:ea typeface="Exo 2 Bold"/>
+                <a:cs typeface="Exo 2 Bold"/>
+              </a:rPr>
+              <a:t>Result</a:t>
+            </a:r>
+          </a:p>
+        </p:txBody>
+      </p:sp>
+      <p:sp>
+        <p:nvSpPr>
+          <p:cNvPr id="26" name="Rectangle 25"/>
+          <p:cNvSpPr/>
+          <p:nvPr/>
+        </p:nvSpPr>
+        <p:spPr>
+          <a:xfrm>
+            <a:off x="841248" y="2898648"/>
+            <a:ext cx="3291840" cy="731520"/>
+          </a:xfrm>
+          <a:prstGeom prst="rect">
+            <a:avLst/>
+          </a:prstGeom>
+          <a:solidFill>
+            <a:srgbClr val="FFFFFF"/>
+          </a:solidFill>
+          <a:ln w="9525">
+            <a:solidFill>
+              <a:srgbClr val="D9DFEA"/>
+            </a:solidFill>
+          </a:ln>
+          <a:effectLst/>
+        </p:spPr>
+        <p:style>
+          <a:lnRef idx="1">
+            <a:schemeClr val="accent1"/>
+          </a:lnRef>
+          <a:fillRef idx="3">
+            <a:schemeClr val="accent1"/>
+          </a:fillRef>
+          <a:effectRef idx="2">
+            <a:schemeClr val="accent1"/>
+          </a:effectRef>
+          <a:fontRef idx="minor">
+            <a:schemeClr val="lt1"/>
+          </a:fontRef>
+        </p:style>
+        <p:txBody>
+          <a:bodyPr rtlCol="0" anchor="ctr"/>
+          <a:lstStyle/>
+          <a:p>
+            <a:pPr algn="ctr"/>
+          </a:p>
+        </p:txBody>
+      </p:sp>
+      <p:sp>
+        <p:nvSpPr>
+          <p:cNvPr id="27" name="TextBox 26"/>
+          <p:cNvSpPr txBox="1"/>
+          <p:nvPr/>
+        </p:nvSpPr>
+        <p:spPr>
+          <a:xfrm>
+            <a:off x="1005840" y="2898648"/>
+            <a:ext cx="3017520" cy="731520"/>
+          </a:xfrm>
+          <a:prstGeom prst="rect">
+            <a:avLst/>
+          </a:prstGeom>
+          <a:noFill/>
+        </p:spPr>
+        <p:txBody>
+          <a:bodyPr wrap="square" anchor="ctr" lIns="0" rIns="0" tIns="0" bIns="0">
+            <a:spAutoFit/>
+          </a:bodyPr>
+          <a:lstStyle/>
+          <a:p>
+            <a:pPr algn="l"/>
+            <a:r>
+              <a:rPr sz="1550" b="1" i="0">
+                <a:solidFill>
+                  <a:srgbClr val="132257"/>
+                </a:solidFill>
+                <a:latin typeface="Exo 2 Bold"/>
+                <a:ea typeface="Exo 2 Bold"/>
+                <a:cs typeface="Exo 2 Bold"/>
+              </a:rPr>
+              <a:t>Long Form Launch</a:t>
+            </a:r>
+          </a:p>
+        </p:txBody>
+      </p:sp>
+      <p:sp>
+        <p:nvSpPr>
+          <p:cNvPr id="28" name="Rectangle 27"/>
+          <p:cNvSpPr/>
+          <p:nvPr/>
+        </p:nvSpPr>
+        <p:spPr>
+          <a:xfrm>
+            <a:off x="4133088" y="2898648"/>
+            <a:ext cx="2743200" cy="731520"/>
+          </a:xfrm>
+          <a:prstGeom prst="rect">
+            <a:avLst/>
+          </a:prstGeom>
+          <a:solidFill>
+            <a:srgbClr val="FFFFFF"/>
+          </a:solidFill>
+          <a:ln w="9525">
+            <a:solidFill>
+              <a:srgbClr val="D9DFEA"/>
+            </a:solidFill>
+          </a:ln>
+          <a:effectLst/>
+        </p:spPr>
+        <p:style>
+          <a:lnRef idx="1">
+            <a:schemeClr val="accent1"/>
+          </a:lnRef>
+          <a:fillRef idx="3">
+            <a:schemeClr val="accent1"/>
+          </a:fillRef>
+          <a:effectRef idx="2">
+            <a:schemeClr val="accent1"/>
+          </a:effectRef>
+          <a:fontRef idx="minor">
+            <a:schemeClr val="lt1"/>
+          </a:fontRef>
+        </p:style>
+        <p:txBody>
+          <a:bodyPr rtlCol="0" anchor="ctr"/>
+          <a:lstStyle/>
+          <a:p>
+            <a:pPr algn="ctr"/>
+          </a:p>
+        </p:txBody>
+      </p:sp>
+      <p:sp>
+        <p:nvSpPr>
+          <p:cNvPr id="29" name="TextBox 28"/>
+          <p:cNvSpPr txBox="1"/>
+          <p:nvPr/>
+        </p:nvSpPr>
+        <p:spPr>
+          <a:xfrm>
+            <a:off x="4297680" y="2898648"/>
+            <a:ext cx="2468880" cy="731520"/>
+          </a:xfrm>
+          <a:prstGeom prst="rect">
+            <a:avLst/>
+          </a:prstGeom>
+          <a:noFill/>
+        </p:spPr>
+        <p:txBody>
+          <a:bodyPr wrap="square" anchor="ctr" lIns="0" rIns="0" tIns="0" bIns="0">
+            <a:spAutoFit/>
+          </a:bodyPr>
+          <a:lstStyle/>
+          <a:p>
+            <a:pPr algn="l"/>
+            <a:r>
+              <a:rPr sz="1550" b="0" i="0">
+                <a:solidFill>
+                  <a:srgbClr val="1F2A44"/>
+                </a:solidFill>
+                <a:latin typeface="Exo 2"/>
+                <a:ea typeface="Exo 2"/>
+                <a:cs typeface="Exo 2"/>
+              </a:rPr>
+              <a:t>Instagram, LinkedIn</a:t>
+            </a:r>
+          </a:p>
+        </p:txBody>
+      </p:sp>
+      <p:sp>
+        <p:nvSpPr>
+          <p:cNvPr id="30" name="Rectangle 29"/>
+          <p:cNvSpPr/>
+          <p:nvPr/>
+        </p:nvSpPr>
+        <p:spPr>
+          <a:xfrm>
+            <a:off x="6876288" y="2898648"/>
+            <a:ext cx="2377440" cy="731520"/>
+          </a:xfrm>
+          <a:prstGeom prst="rect">
+            <a:avLst/>
+          </a:prstGeom>
+          <a:solidFill>
+            <a:srgbClr val="FFFFFF"/>
+          </a:solidFill>
+          <a:ln w="9525">
+            <a:solidFill>
+              <a:srgbClr val="D9DFEA"/>
+            </a:solidFill>
+          </a:ln>
+          <a:effectLst/>
+        </p:spPr>
+        <p:style>
+          <a:lnRef idx="1">
+            <a:schemeClr val="accent1"/>
+          </a:lnRef>
+          <a:fillRef idx="3">
+            <a:schemeClr val="accent1"/>
+          </a:fillRef>
+          <a:effectRef idx="2">
+            <a:schemeClr val="accent1"/>
+          </a:effectRef>
+          <a:fontRef idx="minor">
+            <a:schemeClr val="lt1"/>
+          </a:fontRef>
+        </p:style>
+        <p:txBody>
+          <a:bodyPr rtlCol="0" anchor="ctr"/>
+          <a:lstStyle/>
+          <a:p>
+            <a:pPr algn="ctr"/>
+          </a:p>
+        </p:txBody>
+      </p:sp>
+      <p:sp>
+        <p:nvSpPr>
+          <p:cNvPr id="31" name="TextBox 30"/>
+          <p:cNvSpPr txBox="1"/>
+          <p:nvPr/>
+        </p:nvSpPr>
+        <p:spPr>
+          <a:xfrm>
+            <a:off x="7040880" y="2898648"/>
+            <a:ext cx="2103120" cy="731520"/>
+          </a:xfrm>
+          <a:prstGeom prst="rect">
+            <a:avLst/>
+          </a:prstGeom>
+          <a:noFill/>
+        </p:spPr>
+        <p:txBody>
+          <a:bodyPr wrap="square" anchor="ctr" lIns="0" rIns="0" tIns="0" bIns="0">
+            <a:spAutoFit/>
+          </a:bodyPr>
+          <a:lstStyle/>
+          <a:p>
+            <a:pPr algn="l"/>
+            <a:r>
+              <a:rPr sz="1550" b="0" i="0">
+                <a:solidFill>
+                  <a:srgbClr val="1F2A44"/>
+                </a:solidFill>
+                <a:latin typeface="Exo 2"/>
+                <a:ea typeface="Exo 2"/>
+                <a:cs typeface="Exo 2"/>
+              </a:rPr>
+              <a:t>19 May to 1 Jun</a:t>
+            </a:r>
+          </a:p>
+        </p:txBody>
+      </p:sp>
+      <p:sp>
+        <p:nvSpPr>
+          <p:cNvPr id="32" name="Rectangle 31"/>
+          <p:cNvSpPr/>
+          <p:nvPr/>
+        </p:nvSpPr>
+        <p:spPr>
+          <a:xfrm>
+            <a:off x="9253728" y="2898648"/>
+            <a:ext cx="2148840" cy="731520"/>
+          </a:xfrm>
+          <a:prstGeom prst="rect">
+            <a:avLst/>
+          </a:prstGeom>
+          <a:solidFill>
+            <a:srgbClr val="FFFFFF"/>
+          </a:solidFill>
+          <a:ln w="9525">
+            <a:solidFill>
+              <a:srgbClr val="D9DFEA"/>
+            </a:solidFill>
+          </a:ln>
+          <a:effectLst/>
+        </p:spPr>
+        <p:style>
+          <a:lnRef idx="1">
+            <a:schemeClr val="accent1"/>
+          </a:lnRef>
+          <a:fillRef idx="3">
+            <a:schemeClr val="accent1"/>
+          </a:fillRef>
+          <a:effectRef idx="2">
+            <a:schemeClr val="accent1"/>
+          </a:effectRef>
+          <a:fontRef idx="minor">
+            <a:schemeClr val="lt1"/>
+          </a:fontRef>
+        </p:style>
+        <p:txBody>
+          <a:bodyPr rtlCol="0" anchor="ctr"/>
+          <a:lstStyle/>
+          <a:p>
+            <a:pPr algn="ctr"/>
+          </a:p>
+        </p:txBody>
+      </p:sp>
+      <p:sp>
+        <p:nvSpPr>
+          <p:cNvPr id="33" name="TextBox 32"/>
+          <p:cNvSpPr txBox="1"/>
+          <p:nvPr/>
+        </p:nvSpPr>
+        <p:spPr>
+          <a:xfrm>
+            <a:off x="9418320" y="2898648"/>
+            <a:ext cx="1874520" cy="731520"/>
+          </a:xfrm>
+          <a:prstGeom prst="rect">
+            <a:avLst/>
+          </a:prstGeom>
+          <a:noFill/>
+        </p:spPr>
+        <p:txBody>
+          <a:bodyPr wrap="square" anchor="ctr" lIns="0" rIns="0" tIns="0" bIns="0">
+            <a:spAutoFit/>
+          </a:bodyPr>
+          <a:lstStyle/>
+          <a:p>
+            <a:pPr algn="l"/>
+            <a:r>
+              <a:rPr sz="1550" b="1" i="0">
+                <a:solidFill>
+                  <a:srgbClr val="132257"/>
+                </a:solidFill>
+                <a:latin typeface="Exo 2 Bold"/>
+                <a:ea typeface="Exo 2 Bold"/>
+                <a:cs typeface="Exo 2 Bold"/>
+              </a:rPr>
+              <a:t>1,700</a:t>
+            </a:r>
+          </a:p>
+        </p:txBody>
+      </p:sp>
+      <p:sp>
+        <p:nvSpPr>
+          <p:cNvPr id="34" name="Rectangle 33"/>
+          <p:cNvSpPr/>
+          <p:nvPr/>
+        </p:nvSpPr>
+        <p:spPr>
+          <a:xfrm>
+            <a:off x="11402568" y="2898648"/>
+            <a:ext cx="6053328" cy="731520"/>
+          </a:xfrm>
+          <a:prstGeom prst="rect">
+            <a:avLst/>
+          </a:prstGeom>
+          <a:solidFill>
+            <a:srgbClr val="FFFFFF"/>
+          </a:solidFill>
+          <a:ln w="9525">
+            <a:solidFill>
+              <a:srgbClr val="D9DFEA"/>
+            </a:solidFill>
+          </a:ln>
+          <a:effectLst/>
+        </p:spPr>
+        <p:style>
+          <a:lnRef idx="1">
+            <a:schemeClr val="accent1"/>
+          </a:lnRef>
+          <a:fillRef idx="3">
+            <a:schemeClr val="accent1"/>
+          </a:fillRef>
+          <a:effectRef idx="2">
+            <a:schemeClr val="accent1"/>
+          </a:effectRef>
+          <a:fontRef idx="minor">
+            <a:schemeClr val="lt1"/>
+          </a:fontRef>
+        </p:style>
+        <p:txBody>
+          <a:bodyPr rtlCol="0" anchor="ctr"/>
+          <a:lstStyle/>
+          <a:p>
+            <a:pPr algn="ctr"/>
+          </a:p>
+        </p:txBody>
+      </p:sp>
+      <p:sp>
+        <p:nvSpPr>
+          <p:cNvPr id="35" name="TextBox 34"/>
+          <p:cNvSpPr txBox="1"/>
+          <p:nvPr/>
+        </p:nvSpPr>
+        <p:spPr>
+          <a:xfrm>
+            <a:off x="11567160" y="2898648"/>
+            <a:ext cx="5779008" cy="731520"/>
+          </a:xfrm>
+          <a:prstGeom prst="rect">
+            <a:avLst/>
+          </a:prstGeom>
+          <a:noFill/>
+        </p:spPr>
+        <p:txBody>
+          <a:bodyPr wrap="square" anchor="ctr" lIns="0" rIns="0" tIns="0" bIns="0">
+            <a:spAutoFit/>
+          </a:bodyPr>
+          <a:lstStyle/>
+          <a:p>
+            <a:pPr algn="l"/>
+            <a:r>
+              <a:rPr sz="1450" b="0" i="0">
+                <a:solidFill>
+                  <a:srgbClr val="1F2A44"/>
+                </a:solidFill>
+                <a:latin typeface="Exo 2"/>
+                <a:ea typeface="Exo 2"/>
+                <a:cs typeface="Exo 2"/>
+              </a:rPr>
+              <a:t>231,850 impressions and 3,471 clicks across KSA, Bahrain, Oman, Kuwait</a:t>
+            </a:r>
+          </a:p>
+        </p:txBody>
+      </p:sp>
+      <p:sp>
+        <p:nvSpPr>
+          <p:cNvPr id="36" name="Rectangle 35"/>
+          <p:cNvSpPr/>
+          <p:nvPr/>
+        </p:nvSpPr>
+        <p:spPr>
+          <a:xfrm>
+            <a:off x="841248" y="3630168"/>
+            <a:ext cx="3291840" cy="731520"/>
+          </a:xfrm>
+          <a:prstGeom prst="rect">
+            <a:avLst/>
+          </a:prstGeom>
+          <a:solidFill>
+            <a:srgbClr val="EEF1F8"/>
+          </a:solidFill>
+          <a:ln w="9525">
+            <a:solidFill>
+              <a:srgbClr val="D9DFEA"/>
+            </a:solidFill>
+          </a:ln>
+          <a:effectLst/>
+        </p:spPr>
+        <p:style>
+          <a:lnRef idx="1">
+            <a:schemeClr val="accent1"/>
+          </a:lnRef>
+          <a:fillRef idx="3">
+            <a:schemeClr val="accent1"/>
+          </a:fillRef>
+          <a:effectRef idx="2">
+            <a:schemeClr val="accent1"/>
+          </a:effectRef>
+          <a:fontRef idx="minor">
+            <a:schemeClr val="lt1"/>
+          </a:fontRef>
+        </p:style>
+        <p:txBody>
+          <a:bodyPr rtlCol="0" anchor="ctr"/>
+          <a:lstStyle/>
+          <a:p>
+            <a:pPr algn="ctr"/>
+          </a:p>
+        </p:txBody>
+      </p:sp>
+      <p:sp>
+        <p:nvSpPr>
+          <p:cNvPr id="37" name="TextBox 36"/>
+          <p:cNvSpPr txBox="1"/>
+          <p:nvPr/>
+        </p:nvSpPr>
+        <p:spPr>
+          <a:xfrm>
+            <a:off x="1005840" y="3630168"/>
+            <a:ext cx="3017520" cy="731520"/>
+          </a:xfrm>
+          <a:prstGeom prst="rect">
+            <a:avLst/>
+          </a:prstGeom>
+          <a:noFill/>
+        </p:spPr>
+        <p:txBody>
+          <a:bodyPr wrap="square" anchor="ctr" lIns="0" rIns="0" tIns="0" bIns="0">
+            <a:spAutoFit/>
+          </a:bodyPr>
+          <a:lstStyle/>
+          <a:p>
+            <a:pPr algn="l"/>
+            <a:r>
+              <a:rPr sz="1550" b="1" i="0">
+                <a:solidFill>
+                  <a:srgbClr val="132257"/>
+                </a:solidFill>
+                <a:latin typeface="Exo 2 Bold"/>
+                <a:ea typeface="Exo 2 Bold"/>
+                <a:cs typeface="Exo 2 Bold"/>
+              </a:rPr>
+              <a:t>Astronaut (animation)</a:t>
+            </a:r>
+          </a:p>
+        </p:txBody>
+      </p:sp>
+      <p:sp>
+        <p:nvSpPr>
+          <p:cNvPr id="38" name="Rectangle 37"/>
+          <p:cNvSpPr/>
+          <p:nvPr/>
+        </p:nvSpPr>
+        <p:spPr>
+          <a:xfrm>
+            <a:off x="4133088" y="3630168"/>
+            <a:ext cx="2743200" cy="731520"/>
+          </a:xfrm>
+          <a:prstGeom prst="rect">
+            <a:avLst/>
+          </a:prstGeom>
+          <a:solidFill>
+            <a:srgbClr val="EEF1F8"/>
+          </a:solidFill>
+          <a:ln w="9525">
+            <a:solidFill>
+              <a:srgbClr val="D9DFEA"/>
+            </a:solidFill>
+          </a:ln>
+          <a:effectLst/>
+        </p:spPr>
+        <p:style>
+          <a:lnRef idx="1">
+            <a:schemeClr val="accent1"/>
+          </a:lnRef>
+          <a:fillRef idx="3">
+            <a:schemeClr val="accent1"/>
+          </a:fillRef>
+          <a:effectRef idx="2">
+            <a:schemeClr val="accent1"/>
+          </a:effectRef>
+          <a:fontRef idx="minor">
+            <a:schemeClr val="lt1"/>
+          </a:fontRef>
+        </p:style>
+        <p:txBody>
+          <a:bodyPr rtlCol="0" anchor="ctr"/>
+          <a:lstStyle/>
+          <a:p>
+            <a:pPr algn="ctr"/>
+          </a:p>
+        </p:txBody>
+      </p:sp>
+      <p:sp>
+        <p:nvSpPr>
+          <p:cNvPr id="39" name="TextBox 38"/>
+          <p:cNvSpPr txBox="1"/>
+          <p:nvPr/>
+        </p:nvSpPr>
+        <p:spPr>
+          <a:xfrm>
+            <a:off x="4297680" y="3630168"/>
+            <a:ext cx="2468880" cy="731520"/>
+          </a:xfrm>
+          <a:prstGeom prst="rect">
+            <a:avLst/>
+          </a:prstGeom>
+          <a:noFill/>
+        </p:spPr>
+        <p:txBody>
+          <a:bodyPr wrap="square" anchor="ctr" lIns="0" rIns="0" tIns="0" bIns="0">
+            <a:spAutoFit/>
+          </a:bodyPr>
+          <a:lstStyle/>
+          <a:p>
+            <a:pPr algn="l"/>
+            <a:r>
+              <a:rPr sz="1550" b="0" i="0">
+                <a:solidFill>
+                  <a:srgbClr val="1F2A44"/>
+                </a:solidFill>
+                <a:latin typeface="Exo 2"/>
+                <a:ea typeface="Exo 2"/>
+                <a:cs typeface="Exo 2"/>
+              </a:rPr>
+              <a:t>Instagram, TikTok, X</a:t>
+            </a:r>
+          </a:p>
+        </p:txBody>
+      </p:sp>
+      <p:sp>
+        <p:nvSpPr>
+          <p:cNvPr id="40" name="Rectangle 39"/>
+          <p:cNvSpPr/>
+          <p:nvPr/>
+        </p:nvSpPr>
+        <p:spPr>
+          <a:xfrm>
+            <a:off x="6876288" y="3630168"/>
+            <a:ext cx="2377440" cy="731520"/>
+          </a:xfrm>
+          <a:prstGeom prst="rect">
+            <a:avLst/>
+          </a:prstGeom>
+          <a:solidFill>
+            <a:srgbClr val="EEF1F8"/>
+          </a:solidFill>
+          <a:ln w="9525">
+            <a:solidFill>
+              <a:srgbClr val="D9DFEA"/>
+            </a:solidFill>
+          </a:ln>
+          <a:effectLst/>
+        </p:spPr>
+        <p:style>
+          <a:lnRef idx="1">
+            <a:schemeClr val="accent1"/>
+          </a:lnRef>
+          <a:fillRef idx="3">
+            <a:schemeClr val="accent1"/>
+          </a:fillRef>
+          <a:effectRef idx="2">
+            <a:schemeClr val="accent1"/>
+          </a:effectRef>
+          <a:fontRef idx="minor">
+            <a:schemeClr val="lt1"/>
+          </a:fontRef>
+        </p:style>
+        <p:txBody>
+          <a:bodyPr rtlCol="0" anchor="ctr"/>
+          <a:lstStyle/>
+          <a:p>
+            <a:pPr algn="ctr"/>
+          </a:p>
+        </p:txBody>
+      </p:sp>
+      <p:sp>
+        <p:nvSpPr>
+          <p:cNvPr id="41" name="TextBox 40"/>
+          <p:cNvSpPr txBox="1"/>
+          <p:nvPr/>
+        </p:nvSpPr>
+        <p:spPr>
+          <a:xfrm>
+            <a:off x="7040880" y="3630168"/>
+            <a:ext cx="2103120" cy="731520"/>
+          </a:xfrm>
+          <a:prstGeom prst="rect">
+            <a:avLst/>
+          </a:prstGeom>
+          <a:noFill/>
+        </p:spPr>
+        <p:txBody>
+          <a:bodyPr wrap="square" anchor="ctr" lIns="0" rIns="0" tIns="0" bIns="0">
+            <a:spAutoFit/>
+          </a:bodyPr>
+          <a:lstStyle/>
+          <a:p>
+            <a:pPr algn="l"/>
+            <a:r>
+              <a:rPr sz="1550" b="0" i="0">
+                <a:solidFill>
+                  <a:srgbClr val="1F2A44"/>
+                </a:solidFill>
+                <a:latin typeface="Exo 2"/>
+                <a:ea typeface="Exo 2"/>
+                <a:cs typeface="Exo 2"/>
+              </a:rPr>
+              <a:t>19 May to 1 Jun</a:t>
+            </a:r>
+          </a:p>
+        </p:txBody>
+      </p:sp>
+      <p:sp>
+        <p:nvSpPr>
+          <p:cNvPr id="42" name="Rectangle 41"/>
+          <p:cNvSpPr/>
+          <p:nvPr/>
+        </p:nvSpPr>
+        <p:spPr>
+          <a:xfrm>
+            <a:off x="9253728" y="3630168"/>
+            <a:ext cx="2148840" cy="731520"/>
+          </a:xfrm>
+          <a:prstGeom prst="rect">
+            <a:avLst/>
+          </a:prstGeom>
+          <a:solidFill>
+            <a:srgbClr val="EEF1F8"/>
+          </a:solidFill>
+          <a:ln w="9525">
+            <a:solidFill>
+              <a:srgbClr val="D9DFEA"/>
+            </a:solidFill>
+          </a:ln>
+          <a:effectLst/>
+        </p:spPr>
+        <p:style>
+          <a:lnRef idx="1">
+            <a:schemeClr val="accent1"/>
+          </a:lnRef>
+          <a:fillRef idx="3">
+            <a:schemeClr val="accent1"/>
+          </a:fillRef>
+          <a:effectRef idx="2">
+            <a:schemeClr val="accent1"/>
+          </a:effectRef>
+          <a:fontRef idx="minor">
+            <a:schemeClr val="lt1"/>
+          </a:fontRef>
+        </p:style>
+        <p:txBody>
+          <a:bodyPr rtlCol="0" anchor="ctr"/>
+          <a:lstStyle/>
+          <a:p>
+            <a:pPr algn="ctr"/>
+          </a:p>
+        </p:txBody>
+      </p:sp>
+      <p:sp>
+        <p:nvSpPr>
+          <p:cNvPr id="43" name="TextBox 42"/>
+          <p:cNvSpPr txBox="1"/>
+          <p:nvPr/>
+        </p:nvSpPr>
+        <p:spPr>
+          <a:xfrm>
+            <a:off x="9418320" y="3630168"/>
+            <a:ext cx="1874520" cy="731520"/>
+          </a:xfrm>
+          <a:prstGeom prst="rect">
+            <a:avLst/>
+          </a:prstGeom>
+          <a:noFill/>
+        </p:spPr>
+        <p:txBody>
+          <a:bodyPr wrap="square" anchor="ctr" lIns="0" rIns="0" tIns="0" bIns="0">
+            <a:spAutoFit/>
+          </a:bodyPr>
+          <a:lstStyle/>
+          <a:p>
+            <a:pPr algn="l"/>
+            <a:r>
+              <a:rPr sz="1550" b="1" i="0">
+                <a:solidFill>
+                  <a:srgbClr val="132257"/>
+                </a:solidFill>
+                <a:latin typeface="Exo 2 Bold"/>
+                <a:ea typeface="Exo 2 Bold"/>
+                <a:cs typeface="Exo 2 Bold"/>
+              </a:rPr>
+              <a:t>3,700</a:t>
+            </a:r>
+          </a:p>
+        </p:txBody>
+      </p:sp>
+      <p:sp>
+        <p:nvSpPr>
+          <p:cNvPr id="44" name="Rectangle 43"/>
+          <p:cNvSpPr/>
+          <p:nvPr/>
+        </p:nvSpPr>
+        <p:spPr>
+          <a:xfrm>
+            <a:off x="11402568" y="3630168"/>
+            <a:ext cx="6053328" cy="731520"/>
+          </a:xfrm>
+          <a:prstGeom prst="rect">
+            <a:avLst/>
+          </a:prstGeom>
+          <a:solidFill>
+            <a:srgbClr val="EEF1F8"/>
+          </a:solidFill>
+          <a:ln w="9525">
+            <a:solidFill>
+              <a:srgbClr val="D9DFEA"/>
+            </a:solidFill>
+          </a:ln>
+          <a:effectLst/>
+        </p:spPr>
+        <p:style>
+          <a:lnRef idx="1">
+            <a:schemeClr val="accent1"/>
+          </a:lnRef>
+          <a:fillRef idx="3">
+            <a:schemeClr val="accent1"/>
+          </a:fillRef>
+          <a:effectRef idx="2">
+            <a:schemeClr val="accent1"/>
+          </a:effectRef>
+          <a:fontRef idx="minor">
+            <a:schemeClr val="lt1"/>
+          </a:fontRef>
+        </p:style>
+        <p:txBody>
+          <a:bodyPr rtlCol="0" anchor="ctr"/>
+          <a:lstStyle/>
+          <a:p>
+            <a:pPr algn="ctr"/>
+          </a:p>
+        </p:txBody>
+      </p:sp>
+      <p:sp>
+        <p:nvSpPr>
+          <p:cNvPr id="45" name="TextBox 44"/>
+          <p:cNvSpPr txBox="1"/>
+          <p:nvPr/>
+        </p:nvSpPr>
+        <p:spPr>
+          <a:xfrm>
+            <a:off x="11567160" y="3630168"/>
+            <a:ext cx="5779008" cy="731520"/>
+          </a:xfrm>
+          <a:prstGeom prst="rect">
+            <a:avLst/>
+          </a:prstGeom>
+          <a:noFill/>
+        </p:spPr>
+        <p:txBody>
+          <a:bodyPr wrap="square" anchor="ctr" lIns="0" rIns="0" tIns="0" bIns="0">
+            <a:spAutoFit/>
+          </a:bodyPr>
+          <a:lstStyle/>
+          <a:p>
+            <a:pPr algn="l"/>
+            <a:r>
+              <a:rPr sz="1450" b="0" i="0">
+                <a:solidFill>
+                  <a:srgbClr val="1F2A44"/>
+                </a:solidFill>
+                <a:latin typeface="Exo 2"/>
+                <a:ea typeface="Exo 2"/>
+                <a:cs typeface="Exo 2"/>
+              </a:rPr>
+              <a:t>Highest reach in May, but TikTok traffic was bots</a:t>
+            </a:r>
+          </a:p>
+        </p:txBody>
+      </p:sp>
+      <p:sp>
+        <p:nvSpPr>
+          <p:cNvPr id="46" name="Rectangle 45"/>
+          <p:cNvSpPr/>
+          <p:nvPr/>
+        </p:nvSpPr>
+        <p:spPr>
+          <a:xfrm>
+            <a:off x="841248" y="4361688"/>
+            <a:ext cx="3291840" cy="731520"/>
+          </a:xfrm>
+          <a:prstGeom prst="rect">
+            <a:avLst/>
+          </a:prstGeom>
+          <a:solidFill>
+            <a:srgbClr val="FFFFFF"/>
+          </a:solidFill>
+          <a:ln w="9525">
+            <a:solidFill>
+              <a:srgbClr val="D9DFEA"/>
+            </a:solidFill>
+          </a:ln>
+          <a:effectLst/>
+        </p:spPr>
+        <p:style>
+          <a:lnRef idx="1">
+            <a:schemeClr val="accent1"/>
+          </a:lnRef>
+          <a:fillRef idx="3">
+            <a:schemeClr val="accent1"/>
+          </a:fillRef>
+          <a:effectRef idx="2">
+            <a:schemeClr val="accent1"/>
+          </a:effectRef>
+          <a:fontRef idx="minor">
+            <a:schemeClr val="lt1"/>
+          </a:fontRef>
+        </p:style>
+        <p:txBody>
+          <a:bodyPr rtlCol="0" anchor="ctr"/>
+          <a:lstStyle/>
+          <a:p>
+            <a:pPr algn="ctr"/>
+          </a:p>
+        </p:txBody>
+      </p:sp>
+      <p:sp>
+        <p:nvSpPr>
+          <p:cNvPr id="47" name="TextBox 46"/>
+          <p:cNvSpPr txBox="1"/>
+          <p:nvPr/>
+        </p:nvSpPr>
+        <p:spPr>
+          <a:xfrm>
+            <a:off x="1005840" y="4361688"/>
+            <a:ext cx="3017520" cy="731520"/>
+          </a:xfrm>
+          <a:prstGeom prst="rect">
+            <a:avLst/>
+          </a:prstGeom>
+          <a:noFill/>
+        </p:spPr>
+        <p:txBody>
+          <a:bodyPr wrap="square" anchor="ctr" lIns="0" rIns="0" tIns="0" bIns="0">
+            <a:spAutoFit/>
+          </a:bodyPr>
+          <a:lstStyle/>
+          <a:p>
+            <a:pPr algn="l"/>
+            <a:r>
+              <a:rPr sz="1550" b="1" i="0">
+                <a:solidFill>
+                  <a:srgbClr val="132257"/>
+                </a:solidFill>
+                <a:latin typeface="Exo 2 Bold"/>
+                <a:ea typeface="Exo 2 Bold"/>
+                <a:cs typeface="Exo 2 Bold"/>
+              </a:rPr>
+              <a:t>App Screens</a:t>
+            </a:r>
+          </a:p>
+        </p:txBody>
+      </p:sp>
+      <p:sp>
+        <p:nvSpPr>
+          <p:cNvPr id="48" name="Rectangle 47"/>
+          <p:cNvSpPr/>
+          <p:nvPr/>
+        </p:nvSpPr>
+        <p:spPr>
+          <a:xfrm>
+            <a:off x="4133088" y="4361688"/>
+            <a:ext cx="2743200" cy="731520"/>
+          </a:xfrm>
+          <a:prstGeom prst="rect">
+            <a:avLst/>
+          </a:prstGeom>
+          <a:solidFill>
+            <a:srgbClr val="FFFFFF"/>
+          </a:solidFill>
+          <a:ln w="9525">
+            <a:solidFill>
+              <a:srgbClr val="D9DFEA"/>
+            </a:solidFill>
+          </a:ln>
+          <a:effectLst/>
+        </p:spPr>
+        <p:style>
+          <a:lnRef idx="1">
+            <a:schemeClr val="accent1"/>
+          </a:lnRef>
+          <a:fillRef idx="3">
+            <a:schemeClr val="accent1"/>
+          </a:fillRef>
+          <a:effectRef idx="2">
+            <a:schemeClr val="accent1"/>
+          </a:effectRef>
+          <a:fontRef idx="minor">
+            <a:schemeClr val="lt1"/>
+          </a:fontRef>
+        </p:style>
+        <p:txBody>
+          <a:bodyPr rtlCol="0" anchor="ctr"/>
+          <a:lstStyle/>
+          <a:p>
+            <a:pPr algn="ctr"/>
+          </a:p>
+        </p:txBody>
+      </p:sp>
+      <p:sp>
+        <p:nvSpPr>
+          <p:cNvPr id="49" name="TextBox 48"/>
+          <p:cNvSpPr txBox="1"/>
+          <p:nvPr/>
+        </p:nvSpPr>
+        <p:spPr>
+          <a:xfrm>
+            <a:off x="4297680" y="4361688"/>
+            <a:ext cx="2468880" cy="731520"/>
+          </a:xfrm>
+          <a:prstGeom prst="rect">
+            <a:avLst/>
+          </a:prstGeom>
+          <a:noFill/>
+        </p:spPr>
+        <p:txBody>
+          <a:bodyPr wrap="square" anchor="ctr" lIns="0" rIns="0" tIns="0" bIns="0">
+            <a:spAutoFit/>
+          </a:bodyPr>
+          <a:lstStyle/>
+          <a:p>
+            <a:pPr algn="l"/>
+            <a:r>
+              <a:rPr sz="1550" b="0" i="0">
+                <a:solidFill>
+                  <a:srgbClr val="1F2A44"/>
+                </a:solidFill>
+                <a:latin typeface="Exo 2"/>
+                <a:ea typeface="Exo 2"/>
+                <a:cs typeface="Exo 2"/>
+              </a:rPr>
+              <a:t>X, Saudi only</a:t>
+            </a:r>
+          </a:p>
+        </p:txBody>
+      </p:sp>
+      <p:sp>
+        <p:nvSpPr>
+          <p:cNvPr id="50" name="Rectangle 49"/>
+          <p:cNvSpPr/>
+          <p:nvPr/>
+        </p:nvSpPr>
+        <p:spPr>
+          <a:xfrm>
+            <a:off x="6876288" y="4361688"/>
+            <a:ext cx="2377440" cy="731520"/>
+          </a:xfrm>
+          <a:prstGeom prst="rect">
+            <a:avLst/>
+          </a:prstGeom>
+          <a:solidFill>
+            <a:srgbClr val="FFFFFF"/>
+          </a:solidFill>
+          <a:ln w="9525">
+            <a:solidFill>
+              <a:srgbClr val="D9DFEA"/>
+            </a:solidFill>
+          </a:ln>
+          <a:effectLst/>
+        </p:spPr>
+        <p:style>
+          <a:lnRef idx="1">
+            <a:schemeClr val="accent1"/>
+          </a:lnRef>
+          <a:fillRef idx="3">
+            <a:schemeClr val="accent1"/>
+          </a:fillRef>
+          <a:effectRef idx="2">
+            <a:schemeClr val="accent1"/>
+          </a:effectRef>
+          <a:fontRef idx="minor">
+            <a:schemeClr val="lt1"/>
+          </a:fontRef>
+        </p:style>
+        <p:txBody>
+          <a:bodyPr rtlCol="0" anchor="ctr"/>
+          <a:lstStyle/>
+          <a:p>
+            <a:pPr algn="ctr"/>
+          </a:p>
+        </p:txBody>
+      </p:sp>
+      <p:sp>
+        <p:nvSpPr>
+          <p:cNvPr id="51" name="TextBox 50"/>
+          <p:cNvSpPr txBox="1"/>
+          <p:nvPr/>
+        </p:nvSpPr>
+        <p:spPr>
+          <a:xfrm>
+            <a:off x="7040880" y="4361688"/>
+            <a:ext cx="2103120" cy="731520"/>
+          </a:xfrm>
+          <a:prstGeom prst="rect">
+            <a:avLst/>
+          </a:prstGeom>
+          <a:noFill/>
+        </p:spPr>
+        <p:txBody>
+          <a:bodyPr wrap="square" anchor="ctr" lIns="0" rIns="0" tIns="0" bIns="0">
+            <a:spAutoFit/>
+          </a:bodyPr>
+          <a:lstStyle/>
+          <a:p>
+            <a:pPr algn="l"/>
+            <a:r>
+              <a:rPr sz="1550" b="0" i="0">
+                <a:solidFill>
+                  <a:srgbClr val="1F2A44"/>
+                </a:solidFill>
+                <a:latin typeface="Exo 2"/>
+                <a:ea typeface="Exo 2"/>
+                <a:cs typeface="Exo 2"/>
+              </a:rPr>
+              <a:t>4 to 13 Jun</a:t>
+            </a:r>
+          </a:p>
+        </p:txBody>
+      </p:sp>
+      <p:sp>
+        <p:nvSpPr>
+          <p:cNvPr id="52" name="Rectangle 51"/>
+          <p:cNvSpPr/>
+          <p:nvPr/>
+        </p:nvSpPr>
+        <p:spPr>
+          <a:xfrm>
+            <a:off x="9253728" y="4361688"/>
+            <a:ext cx="2148840" cy="731520"/>
+          </a:xfrm>
+          <a:prstGeom prst="rect">
+            <a:avLst/>
+          </a:prstGeom>
+          <a:solidFill>
+            <a:srgbClr val="FFFFFF"/>
+          </a:solidFill>
+          <a:ln w="9525">
+            <a:solidFill>
+              <a:srgbClr val="D9DFEA"/>
+            </a:solidFill>
+          </a:ln>
+          <a:effectLst/>
+        </p:spPr>
+        <p:style>
+          <a:lnRef idx="1">
+            <a:schemeClr val="accent1"/>
+          </a:lnRef>
+          <a:fillRef idx="3">
+            <a:schemeClr val="accent1"/>
+          </a:fillRef>
+          <a:effectRef idx="2">
+            <a:schemeClr val="accent1"/>
+          </a:effectRef>
+          <a:fontRef idx="minor">
+            <a:schemeClr val="lt1"/>
+          </a:fontRef>
+        </p:style>
+        <p:txBody>
+          <a:bodyPr rtlCol="0" anchor="ctr"/>
+          <a:lstStyle/>
+          <a:p>
+            <a:pPr algn="ctr"/>
+          </a:p>
+        </p:txBody>
+      </p:sp>
+      <p:sp>
+        <p:nvSpPr>
+          <p:cNvPr id="53" name="TextBox 52"/>
+          <p:cNvSpPr txBox="1"/>
+          <p:nvPr/>
+        </p:nvSpPr>
+        <p:spPr>
+          <a:xfrm>
+            <a:off x="9418320" y="4361688"/>
+            <a:ext cx="1874520" cy="731520"/>
+          </a:xfrm>
+          <a:prstGeom prst="rect">
+            <a:avLst/>
+          </a:prstGeom>
+          <a:noFill/>
+        </p:spPr>
+        <p:txBody>
+          <a:bodyPr wrap="square" anchor="ctr" lIns="0" rIns="0" tIns="0" bIns="0">
+            <a:spAutoFit/>
+          </a:bodyPr>
+          <a:lstStyle/>
+          <a:p>
+            <a:pPr algn="l"/>
+            <a:r>
+              <a:rPr sz="1550" b="1" i="0">
+                <a:solidFill>
+                  <a:srgbClr val="132257"/>
+                </a:solidFill>
+                <a:latin typeface="Exo 2 Bold"/>
+                <a:ea typeface="Exo 2 Bold"/>
+                <a:cs typeface="Exo 2 Bold"/>
+              </a:rPr>
+              <a:t>500</a:t>
+            </a:r>
+          </a:p>
+        </p:txBody>
+      </p:sp>
+      <p:sp>
+        <p:nvSpPr>
+          <p:cNvPr id="54" name="Rectangle 53"/>
+          <p:cNvSpPr/>
+          <p:nvPr/>
+        </p:nvSpPr>
+        <p:spPr>
+          <a:xfrm>
+            <a:off x="11402568" y="4361688"/>
+            <a:ext cx="6053328" cy="731520"/>
+          </a:xfrm>
+          <a:prstGeom prst="rect">
+            <a:avLst/>
+          </a:prstGeom>
+          <a:solidFill>
+            <a:srgbClr val="FFFFFF"/>
+          </a:solidFill>
+          <a:ln w="9525">
+            <a:solidFill>
+              <a:srgbClr val="D9DFEA"/>
+            </a:solidFill>
+          </a:ln>
+          <a:effectLst/>
+        </p:spPr>
+        <p:style>
+          <a:lnRef idx="1">
+            <a:schemeClr val="accent1"/>
+          </a:lnRef>
+          <a:fillRef idx="3">
+            <a:schemeClr val="accent1"/>
+          </a:fillRef>
+          <a:effectRef idx="2">
+            <a:schemeClr val="accent1"/>
+          </a:effectRef>
+          <a:fontRef idx="minor">
+            <a:schemeClr val="lt1"/>
+          </a:fontRef>
+        </p:style>
+        <p:txBody>
+          <a:bodyPr rtlCol="0" anchor="ctr"/>
+          <a:lstStyle/>
+          <a:p>
+            <a:pPr algn="ctr"/>
+          </a:p>
+        </p:txBody>
+      </p:sp>
+      <p:sp>
+        <p:nvSpPr>
+          <p:cNvPr id="55" name="TextBox 54"/>
+          <p:cNvSpPr txBox="1"/>
+          <p:nvPr/>
+        </p:nvSpPr>
+        <p:spPr>
+          <a:xfrm>
+            <a:off x="11567160" y="4361688"/>
+            <a:ext cx="5779008" cy="731520"/>
+          </a:xfrm>
+          <a:prstGeom prst="rect">
+            <a:avLst/>
+          </a:prstGeom>
+          <a:noFill/>
+        </p:spPr>
+        <p:txBody>
+          <a:bodyPr wrap="square" anchor="ctr" lIns="0" rIns="0" tIns="0" bIns="0">
+            <a:spAutoFit/>
+          </a:bodyPr>
+          <a:lstStyle/>
+          <a:p>
+            <a:pPr algn="l"/>
+            <a:r>
+              <a:rPr sz="1450" b="0" i="0">
+                <a:solidFill>
+                  <a:srgbClr val="1F2A44"/>
+                </a:solidFill>
+                <a:latin typeface="Exo 2"/>
+                <a:ea typeface="Exo 2"/>
+                <a:cs typeface="Exo 2"/>
+              </a:rPr>
+              <a:t>Product test in Jeddah, Dammam and Khobar</a:t>
+            </a:r>
+          </a:p>
+        </p:txBody>
+      </p:sp>
+      <p:sp>
+        <p:nvSpPr>
+          <p:cNvPr id="56" name="Rectangle 55"/>
+          <p:cNvSpPr/>
+          <p:nvPr/>
+        </p:nvSpPr>
+        <p:spPr>
+          <a:xfrm>
+            <a:off x="841248" y="5093207"/>
+            <a:ext cx="3291840" cy="731520"/>
+          </a:xfrm>
+          <a:prstGeom prst="rect">
+            <a:avLst/>
+          </a:prstGeom>
+          <a:solidFill>
+            <a:srgbClr val="EEF1F8"/>
+          </a:solidFill>
+          <a:ln w="9525">
+            <a:solidFill>
+              <a:srgbClr val="D9DFEA"/>
+            </a:solidFill>
+          </a:ln>
+          <a:effectLst/>
+        </p:spPr>
+        <p:style>
+          <a:lnRef idx="1">
+            <a:schemeClr val="accent1"/>
+          </a:lnRef>
+          <a:fillRef idx="3">
+            <a:schemeClr val="accent1"/>
+          </a:fillRef>
+          <a:effectRef idx="2">
+            <a:schemeClr val="accent1"/>
+          </a:effectRef>
+          <a:fontRef idx="minor">
+            <a:schemeClr val="lt1"/>
+          </a:fontRef>
+        </p:style>
+        <p:txBody>
+          <a:bodyPr rtlCol="0" anchor="ctr"/>
+          <a:lstStyle/>
+          <a:p>
+            <a:pPr algn="ctr"/>
+          </a:p>
+        </p:txBody>
+      </p:sp>
+      <p:sp>
+        <p:nvSpPr>
+          <p:cNvPr id="57" name="TextBox 56"/>
+          <p:cNvSpPr txBox="1"/>
+          <p:nvPr/>
+        </p:nvSpPr>
+        <p:spPr>
+          <a:xfrm>
+            <a:off x="1005840" y="5093207"/>
+            <a:ext cx="3017520" cy="731520"/>
+          </a:xfrm>
+          <a:prstGeom prst="rect">
+            <a:avLst/>
+          </a:prstGeom>
+          <a:noFill/>
+        </p:spPr>
+        <p:txBody>
+          <a:bodyPr wrap="square" anchor="ctr" lIns="0" rIns="0" tIns="0" bIns="0">
+            <a:spAutoFit/>
+          </a:bodyPr>
+          <a:lstStyle/>
+          <a:p>
+            <a:pPr algn="l"/>
+            <a:r>
+              <a:rPr sz="1550" b="1" i="0">
+                <a:solidFill>
+                  <a:srgbClr val="132257"/>
+                </a:solidFill>
+                <a:latin typeface="Exo 2 Bold"/>
+                <a:ea typeface="Exo 2 Bold"/>
+                <a:cs typeface="Exo 2 Bold"/>
+              </a:rPr>
+              <a:t>GCC Relaunch</a:t>
+            </a:r>
+          </a:p>
+        </p:txBody>
+      </p:sp>
+      <p:sp>
+        <p:nvSpPr>
+          <p:cNvPr id="58" name="Rectangle 57"/>
+          <p:cNvSpPr/>
+          <p:nvPr/>
+        </p:nvSpPr>
+        <p:spPr>
+          <a:xfrm>
+            <a:off x="4133088" y="5093207"/>
+            <a:ext cx="2743200" cy="731520"/>
+          </a:xfrm>
+          <a:prstGeom prst="rect">
+            <a:avLst/>
+          </a:prstGeom>
+          <a:solidFill>
+            <a:srgbClr val="EEF1F8"/>
+          </a:solidFill>
+          <a:ln w="9525">
+            <a:solidFill>
+              <a:srgbClr val="D9DFEA"/>
+            </a:solidFill>
+          </a:ln>
+          <a:effectLst/>
+        </p:spPr>
+        <p:style>
+          <a:lnRef idx="1">
+            <a:schemeClr val="accent1"/>
+          </a:lnRef>
+          <a:fillRef idx="3">
+            <a:schemeClr val="accent1"/>
+          </a:fillRef>
+          <a:effectRef idx="2">
+            <a:schemeClr val="accent1"/>
+          </a:effectRef>
+          <a:fontRef idx="minor">
+            <a:schemeClr val="lt1"/>
+          </a:fontRef>
+        </p:style>
+        <p:txBody>
+          <a:bodyPr rtlCol="0" anchor="ctr"/>
+          <a:lstStyle/>
+          <a:p>
+            <a:pPr algn="ctr"/>
+          </a:p>
+        </p:txBody>
+      </p:sp>
+      <p:sp>
+        <p:nvSpPr>
+          <p:cNvPr id="59" name="TextBox 58"/>
+          <p:cNvSpPr txBox="1"/>
+          <p:nvPr/>
+        </p:nvSpPr>
+        <p:spPr>
+          <a:xfrm>
+            <a:off x="4297680" y="5093207"/>
+            <a:ext cx="2468880" cy="731520"/>
+          </a:xfrm>
+          <a:prstGeom prst="rect">
+            <a:avLst/>
+          </a:prstGeom>
+          <a:noFill/>
+        </p:spPr>
+        <p:txBody>
+          <a:bodyPr wrap="square" anchor="ctr" lIns="0" rIns="0" tIns="0" bIns="0">
+            <a:spAutoFit/>
+          </a:bodyPr>
+          <a:lstStyle/>
+          <a:p>
+            <a:pPr algn="l"/>
+            <a:r>
+              <a:rPr sz="1550" b="0" i="0">
+                <a:solidFill>
+                  <a:srgbClr val="1F2A44"/>
+                </a:solidFill>
+                <a:latin typeface="Exo 2"/>
+                <a:ea typeface="Exo 2"/>
+                <a:cs typeface="Exo 2"/>
+              </a:rPr>
+              <a:t>Instagram, X, LinkedIn</a:t>
+            </a:r>
+          </a:p>
+        </p:txBody>
+      </p:sp>
+      <p:sp>
+        <p:nvSpPr>
+          <p:cNvPr id="60" name="Rectangle 59"/>
+          <p:cNvSpPr/>
+          <p:nvPr/>
+        </p:nvSpPr>
+        <p:spPr>
+          <a:xfrm>
+            <a:off x="6876288" y="5093207"/>
+            <a:ext cx="2377440" cy="731520"/>
+          </a:xfrm>
+          <a:prstGeom prst="rect">
+            <a:avLst/>
+          </a:prstGeom>
+          <a:solidFill>
+            <a:srgbClr val="EEF1F8"/>
+          </a:solidFill>
+          <a:ln w="9525">
+            <a:solidFill>
+              <a:srgbClr val="D9DFEA"/>
+            </a:solidFill>
+          </a:ln>
+          <a:effectLst/>
+        </p:spPr>
+        <p:style>
+          <a:lnRef idx="1">
+            <a:schemeClr val="accent1"/>
+          </a:lnRef>
+          <a:fillRef idx="3">
+            <a:schemeClr val="accent1"/>
+          </a:fillRef>
+          <a:effectRef idx="2">
+            <a:schemeClr val="accent1"/>
+          </a:effectRef>
+          <a:fontRef idx="minor">
+            <a:schemeClr val="lt1"/>
+          </a:fontRef>
+        </p:style>
+        <p:txBody>
+          <a:bodyPr rtlCol="0" anchor="ctr"/>
+          <a:lstStyle/>
+          <a:p>
+            <a:pPr algn="ctr"/>
+          </a:p>
+        </p:txBody>
+      </p:sp>
+      <p:sp>
+        <p:nvSpPr>
+          <p:cNvPr id="61" name="TextBox 60"/>
+          <p:cNvSpPr txBox="1"/>
+          <p:nvPr/>
+        </p:nvSpPr>
+        <p:spPr>
+          <a:xfrm>
+            <a:off x="7040880" y="5093207"/>
+            <a:ext cx="2103120" cy="731520"/>
+          </a:xfrm>
+          <a:prstGeom prst="rect">
+            <a:avLst/>
+          </a:prstGeom>
+          <a:noFill/>
+        </p:spPr>
+        <p:txBody>
+          <a:bodyPr wrap="square" anchor="ctr" lIns="0" rIns="0" tIns="0" bIns="0">
+            <a:spAutoFit/>
+          </a:bodyPr>
+          <a:lstStyle/>
+          <a:p>
+            <a:pPr algn="l"/>
+            <a:r>
+              <a:rPr sz="1550" b="0" i="0">
+                <a:solidFill>
+                  <a:srgbClr val="1F2A44"/>
+                </a:solidFill>
+                <a:latin typeface="Exo 2"/>
+                <a:ea typeface="Exo 2"/>
+                <a:cs typeface="Exo 2"/>
+              </a:rPr>
+              <a:t>8 Jun to 8 Jul</a:t>
+            </a:r>
+          </a:p>
+        </p:txBody>
+      </p:sp>
+      <p:sp>
+        <p:nvSpPr>
+          <p:cNvPr id="62" name="Rectangle 61"/>
+          <p:cNvSpPr/>
+          <p:nvPr/>
+        </p:nvSpPr>
+        <p:spPr>
+          <a:xfrm>
+            <a:off x="9253728" y="5093207"/>
+            <a:ext cx="2148840" cy="731520"/>
+          </a:xfrm>
+          <a:prstGeom prst="rect">
+            <a:avLst/>
+          </a:prstGeom>
+          <a:solidFill>
+            <a:srgbClr val="EEF1F8"/>
+          </a:solidFill>
+          <a:ln w="9525">
+            <a:solidFill>
+              <a:srgbClr val="D9DFEA"/>
+            </a:solidFill>
+          </a:ln>
+          <a:effectLst/>
+        </p:spPr>
+        <p:style>
+          <a:lnRef idx="1">
+            <a:schemeClr val="accent1"/>
+          </a:lnRef>
+          <a:fillRef idx="3">
+            <a:schemeClr val="accent1"/>
+          </a:fillRef>
+          <a:effectRef idx="2">
+            <a:schemeClr val="accent1"/>
+          </a:effectRef>
+          <a:fontRef idx="minor">
+            <a:schemeClr val="lt1"/>
+          </a:fontRef>
+        </p:style>
+        <p:txBody>
+          <a:bodyPr rtlCol="0" anchor="ctr"/>
+          <a:lstStyle/>
+          <a:p>
+            <a:pPr algn="ctr"/>
+          </a:p>
+        </p:txBody>
+      </p:sp>
+      <p:sp>
+        <p:nvSpPr>
+          <p:cNvPr id="63" name="TextBox 62"/>
+          <p:cNvSpPr txBox="1"/>
+          <p:nvPr/>
+        </p:nvSpPr>
+        <p:spPr>
+          <a:xfrm>
+            <a:off x="9418320" y="5093207"/>
+            <a:ext cx="1874520" cy="731520"/>
+          </a:xfrm>
+          <a:prstGeom prst="rect">
+            <a:avLst/>
+          </a:prstGeom>
+          <a:noFill/>
+        </p:spPr>
+        <p:txBody>
+          <a:bodyPr wrap="square" anchor="ctr" lIns="0" rIns="0" tIns="0" bIns="0">
+            <a:spAutoFit/>
+          </a:bodyPr>
+          <a:lstStyle/>
+          <a:p>
+            <a:pPr algn="l"/>
+            <a:r>
+              <a:rPr sz="1550" b="1" i="0">
+                <a:solidFill>
+                  <a:srgbClr val="132257"/>
+                </a:solidFill>
+                <a:latin typeface="Exo 2 Bold"/>
+                <a:ea typeface="Exo 2 Bold"/>
+                <a:cs typeface="Exo 2 Bold"/>
+              </a:rPr>
+              <a:t>6,700</a:t>
+            </a:r>
+          </a:p>
+        </p:txBody>
+      </p:sp>
+      <p:sp>
+        <p:nvSpPr>
+          <p:cNvPr id="64" name="Rectangle 63"/>
+          <p:cNvSpPr/>
+          <p:nvPr/>
+        </p:nvSpPr>
+        <p:spPr>
+          <a:xfrm>
+            <a:off x="11402568" y="5093207"/>
+            <a:ext cx="6053328" cy="731520"/>
+          </a:xfrm>
+          <a:prstGeom prst="rect">
+            <a:avLst/>
+          </a:prstGeom>
+          <a:solidFill>
+            <a:srgbClr val="EEF1F8"/>
+          </a:solidFill>
+          <a:ln w="9525">
+            <a:solidFill>
+              <a:srgbClr val="D9DFEA"/>
+            </a:solidFill>
+          </a:ln>
+          <a:effectLst/>
+        </p:spPr>
+        <p:style>
+          <a:lnRef idx="1">
+            <a:schemeClr val="accent1"/>
+          </a:lnRef>
+          <a:fillRef idx="3">
+            <a:schemeClr val="accent1"/>
+          </a:fillRef>
+          <a:effectRef idx="2">
+            <a:schemeClr val="accent1"/>
+          </a:effectRef>
+          <a:fontRef idx="minor">
+            <a:schemeClr val="lt1"/>
+          </a:fontRef>
+        </p:style>
+        <p:txBody>
+          <a:bodyPr rtlCol="0" anchor="ctr"/>
+          <a:lstStyle/>
+          <a:p>
+            <a:pPr algn="ctr"/>
+          </a:p>
+        </p:txBody>
+      </p:sp>
+      <p:sp>
+        <p:nvSpPr>
+          <p:cNvPr id="65" name="TextBox 64"/>
+          <p:cNvSpPr txBox="1"/>
+          <p:nvPr/>
+        </p:nvSpPr>
+        <p:spPr>
+          <a:xfrm>
+            <a:off x="11567160" y="5093207"/>
+            <a:ext cx="5779008" cy="731520"/>
+          </a:xfrm>
+          <a:prstGeom prst="rect">
+            <a:avLst/>
+          </a:prstGeom>
+          <a:noFill/>
+        </p:spPr>
+        <p:txBody>
+          <a:bodyPr wrap="square" anchor="ctr" lIns="0" rIns="0" tIns="0" bIns="0">
+            <a:spAutoFit/>
+          </a:bodyPr>
+          <a:lstStyle/>
+          <a:p>
+            <a:pPr algn="l"/>
+            <a:r>
+              <a:rPr sz="1450" b="0" i="0">
+                <a:solidFill>
+                  <a:srgbClr val="1F2A44"/>
+                </a:solidFill>
+                <a:latin typeface="Exo 2"/>
+                <a:ea typeface="Exo 2"/>
+                <a:cs typeface="Exo 2"/>
+              </a:rPr>
+              <a:t>Followers grew on every channel in June</a:t>
+            </a:r>
+          </a:p>
+        </p:txBody>
+      </p:sp>
+      <p:sp>
+        <p:nvSpPr>
+          <p:cNvPr id="66" name="Rectangle 65"/>
+          <p:cNvSpPr/>
+          <p:nvPr/>
+        </p:nvSpPr>
+        <p:spPr>
+          <a:xfrm>
+            <a:off x="841248" y="5824727"/>
+            <a:ext cx="3291840" cy="731520"/>
+          </a:xfrm>
+          <a:prstGeom prst="rect">
+            <a:avLst/>
+          </a:prstGeom>
+          <a:solidFill>
+            <a:srgbClr val="FFFFFF"/>
+          </a:solidFill>
+          <a:ln w="9525">
+            <a:solidFill>
+              <a:srgbClr val="D9DFEA"/>
+            </a:solidFill>
+          </a:ln>
+          <a:effectLst/>
+        </p:spPr>
+        <p:style>
+          <a:lnRef idx="1">
+            <a:schemeClr val="accent1"/>
+          </a:lnRef>
+          <a:fillRef idx="3">
+            <a:schemeClr val="accent1"/>
+          </a:fillRef>
+          <a:effectRef idx="2">
+            <a:schemeClr val="accent1"/>
+          </a:effectRef>
+          <a:fontRef idx="minor">
+            <a:schemeClr val="lt1"/>
+          </a:fontRef>
+        </p:style>
+        <p:txBody>
+          <a:bodyPr rtlCol="0" anchor="ctr"/>
+          <a:lstStyle/>
+          <a:p>
+            <a:pPr algn="ctr"/>
+          </a:p>
+        </p:txBody>
+      </p:sp>
+      <p:sp>
+        <p:nvSpPr>
+          <p:cNvPr id="67" name="TextBox 66"/>
+          <p:cNvSpPr txBox="1"/>
+          <p:nvPr/>
+        </p:nvSpPr>
+        <p:spPr>
+          <a:xfrm>
+            <a:off x="1005840" y="5824727"/>
+            <a:ext cx="3017520" cy="731520"/>
+          </a:xfrm>
+          <a:prstGeom prst="rect">
+            <a:avLst/>
+          </a:prstGeom>
+          <a:noFill/>
+        </p:spPr>
+        <p:txBody>
+          <a:bodyPr wrap="square" anchor="ctr" lIns="0" rIns="0" tIns="0" bIns="0">
+            <a:spAutoFit/>
+          </a:bodyPr>
+          <a:lstStyle/>
+          <a:p>
+            <a:pPr algn="l"/>
+            <a:r>
+              <a:rPr sz="1550" b="1" i="0">
+                <a:solidFill>
+                  <a:srgbClr val="132257"/>
+                </a:solidFill>
+                <a:latin typeface="Exo 2 Bold"/>
+                <a:ea typeface="Exo 2 Bold"/>
+                <a:cs typeface="Exo 2 Bold"/>
+              </a:rPr>
+              <a:t>Mention &amp; Win</a:t>
+            </a:r>
+          </a:p>
+        </p:txBody>
+      </p:sp>
+      <p:sp>
+        <p:nvSpPr>
+          <p:cNvPr id="68" name="Rectangle 67"/>
+          <p:cNvSpPr/>
+          <p:nvPr/>
+        </p:nvSpPr>
+        <p:spPr>
+          <a:xfrm>
+            <a:off x="4133088" y="5824727"/>
+            <a:ext cx="2743200" cy="731520"/>
+          </a:xfrm>
+          <a:prstGeom prst="rect">
+            <a:avLst/>
+          </a:prstGeom>
+          <a:solidFill>
+            <a:srgbClr val="FFFFFF"/>
+          </a:solidFill>
+          <a:ln w="9525">
+            <a:solidFill>
+              <a:srgbClr val="D9DFEA"/>
+            </a:solidFill>
+          </a:ln>
+          <a:effectLst/>
+        </p:spPr>
+        <p:style>
+          <a:lnRef idx="1">
+            <a:schemeClr val="accent1"/>
+          </a:lnRef>
+          <a:fillRef idx="3">
+            <a:schemeClr val="accent1"/>
+          </a:fillRef>
+          <a:effectRef idx="2">
+            <a:schemeClr val="accent1"/>
+          </a:effectRef>
+          <a:fontRef idx="minor">
+            <a:schemeClr val="lt1"/>
+          </a:fontRef>
+        </p:style>
+        <p:txBody>
+          <a:bodyPr rtlCol="0" anchor="ctr"/>
+          <a:lstStyle/>
+          <a:p>
+            <a:pPr algn="ctr"/>
+          </a:p>
+        </p:txBody>
+      </p:sp>
+      <p:sp>
+        <p:nvSpPr>
+          <p:cNvPr id="69" name="TextBox 68"/>
+          <p:cNvSpPr txBox="1"/>
+          <p:nvPr/>
+        </p:nvSpPr>
+        <p:spPr>
+          <a:xfrm>
+            <a:off x="4297680" y="5824727"/>
+            <a:ext cx="2468880" cy="731520"/>
+          </a:xfrm>
+          <a:prstGeom prst="rect">
+            <a:avLst/>
+          </a:prstGeom>
+          <a:noFill/>
+        </p:spPr>
+        <p:txBody>
+          <a:bodyPr wrap="square" anchor="ctr" lIns="0" rIns="0" tIns="0" bIns="0">
+            <a:spAutoFit/>
+          </a:bodyPr>
+          <a:lstStyle/>
+          <a:p>
+            <a:pPr algn="l"/>
+            <a:r>
+              <a:rPr sz="1550" b="0" i="0">
+                <a:solidFill>
+                  <a:srgbClr val="1F2A44"/>
+                </a:solidFill>
+                <a:latin typeface="Exo 2"/>
+                <a:ea typeface="Exo 2"/>
+                <a:cs typeface="Exo 2"/>
+              </a:rPr>
+              <a:t>Instagram, GCC</a:t>
+            </a:r>
+          </a:p>
+        </p:txBody>
+      </p:sp>
+      <p:sp>
+        <p:nvSpPr>
+          <p:cNvPr id="70" name="Rectangle 69"/>
+          <p:cNvSpPr/>
+          <p:nvPr/>
+        </p:nvSpPr>
+        <p:spPr>
+          <a:xfrm>
+            <a:off x="6876288" y="5824727"/>
+            <a:ext cx="2377440" cy="731520"/>
+          </a:xfrm>
+          <a:prstGeom prst="rect">
+            <a:avLst/>
+          </a:prstGeom>
+          <a:solidFill>
+            <a:srgbClr val="FFFFFF"/>
+          </a:solidFill>
+          <a:ln w="9525">
+            <a:solidFill>
+              <a:srgbClr val="D9DFEA"/>
+            </a:solidFill>
+          </a:ln>
+          <a:effectLst/>
+        </p:spPr>
+        <p:style>
+          <a:lnRef idx="1">
+            <a:schemeClr val="accent1"/>
+          </a:lnRef>
+          <a:fillRef idx="3">
+            <a:schemeClr val="accent1"/>
+          </a:fillRef>
+          <a:effectRef idx="2">
+            <a:schemeClr val="accent1"/>
+          </a:effectRef>
+          <a:fontRef idx="minor">
+            <a:schemeClr val="lt1"/>
+          </a:fontRef>
+        </p:style>
+        <p:txBody>
+          <a:bodyPr rtlCol="0" anchor="ctr"/>
+          <a:lstStyle/>
+          <a:p>
+            <a:pPr algn="ctr"/>
+          </a:p>
+        </p:txBody>
+      </p:sp>
+      <p:sp>
+        <p:nvSpPr>
+          <p:cNvPr id="71" name="TextBox 70"/>
+          <p:cNvSpPr txBox="1"/>
+          <p:nvPr/>
+        </p:nvSpPr>
+        <p:spPr>
+          <a:xfrm>
+            <a:off x="7040880" y="5824727"/>
+            <a:ext cx="2103120" cy="731520"/>
+          </a:xfrm>
+          <a:prstGeom prst="rect">
+            <a:avLst/>
+          </a:prstGeom>
+          <a:noFill/>
+        </p:spPr>
+        <p:txBody>
+          <a:bodyPr wrap="square" anchor="ctr" lIns="0" rIns="0" tIns="0" bIns="0">
+            <a:spAutoFit/>
+          </a:bodyPr>
+          <a:lstStyle/>
+          <a:p>
+            <a:pPr algn="l"/>
+            <a:r>
+              <a:rPr sz="1550" b="0" i="0">
+                <a:solidFill>
+                  <a:srgbClr val="1F2A44"/>
+                </a:solidFill>
+                <a:latin typeface="Exo 2"/>
+                <a:ea typeface="Exo 2"/>
+                <a:cs typeface="Exo 2"/>
+              </a:rPr>
+              <a:t>Monthly since Jun</a:t>
+            </a:r>
+          </a:p>
+        </p:txBody>
+      </p:sp>
+      <p:sp>
+        <p:nvSpPr>
+          <p:cNvPr id="72" name="Rectangle 71"/>
+          <p:cNvSpPr/>
+          <p:nvPr/>
+        </p:nvSpPr>
+        <p:spPr>
+          <a:xfrm>
+            <a:off x="9253728" y="5824727"/>
+            <a:ext cx="2148840" cy="731520"/>
+          </a:xfrm>
+          <a:prstGeom prst="rect">
+            <a:avLst/>
+          </a:prstGeom>
+          <a:solidFill>
+            <a:srgbClr val="FFFFFF"/>
+          </a:solidFill>
+          <a:ln w="9525">
+            <a:solidFill>
+              <a:srgbClr val="D9DFEA"/>
+            </a:solidFill>
+          </a:ln>
+          <a:effectLst/>
+        </p:spPr>
+        <p:style>
+          <a:lnRef idx="1">
+            <a:schemeClr val="accent1"/>
+          </a:lnRef>
+          <a:fillRef idx="3">
+            <a:schemeClr val="accent1"/>
+          </a:fillRef>
+          <a:effectRef idx="2">
+            <a:schemeClr val="accent1"/>
+          </a:effectRef>
+          <a:fontRef idx="minor">
+            <a:schemeClr val="lt1"/>
+          </a:fontRef>
+        </p:style>
+        <p:txBody>
+          <a:bodyPr rtlCol="0" anchor="ctr"/>
+          <a:lstStyle/>
+          <a:p>
+            <a:pPr algn="ctr"/>
+          </a:p>
+        </p:txBody>
+      </p:sp>
+      <p:sp>
+        <p:nvSpPr>
+          <p:cNvPr id="73" name="TextBox 72"/>
+          <p:cNvSpPr txBox="1"/>
+          <p:nvPr/>
+        </p:nvSpPr>
+        <p:spPr>
+          <a:xfrm>
+            <a:off x="9418320" y="5824727"/>
+            <a:ext cx="1874520" cy="731520"/>
+          </a:xfrm>
+          <a:prstGeom prst="rect">
+            <a:avLst/>
+          </a:prstGeom>
+          <a:noFill/>
+        </p:spPr>
+        <p:txBody>
+          <a:bodyPr wrap="square" anchor="ctr" lIns="0" rIns="0" tIns="0" bIns="0">
+            <a:spAutoFit/>
+          </a:bodyPr>
+          <a:lstStyle/>
+          <a:p>
+            <a:pPr algn="l"/>
+            <a:r>
+              <a:rPr sz="1550" b="1" i="0">
+                <a:solidFill>
+                  <a:srgbClr val="132257"/>
+                </a:solidFill>
+                <a:latin typeface="Exo 2 Bold"/>
+                <a:ea typeface="Exo 2 Bold"/>
+                <a:cs typeface="Exo 2 Bold"/>
+              </a:rPr>
+              <a:t>500 prize + ads</a:t>
+            </a:r>
+          </a:p>
+        </p:txBody>
+      </p:sp>
+      <p:sp>
+        <p:nvSpPr>
+          <p:cNvPr id="74" name="Rectangle 73"/>
+          <p:cNvSpPr/>
+          <p:nvPr/>
+        </p:nvSpPr>
+        <p:spPr>
+          <a:xfrm>
+            <a:off x="11402568" y="5824727"/>
+            <a:ext cx="6053328" cy="731520"/>
+          </a:xfrm>
+          <a:prstGeom prst="rect">
+            <a:avLst/>
+          </a:prstGeom>
+          <a:solidFill>
+            <a:srgbClr val="FFFFFF"/>
+          </a:solidFill>
+          <a:ln w="9525">
+            <a:solidFill>
+              <a:srgbClr val="D9DFEA"/>
+            </a:solidFill>
+          </a:ln>
+          <a:effectLst/>
+        </p:spPr>
+        <p:style>
+          <a:lnRef idx="1">
+            <a:schemeClr val="accent1"/>
+          </a:lnRef>
+          <a:fillRef idx="3">
+            <a:schemeClr val="accent1"/>
+          </a:fillRef>
+          <a:effectRef idx="2">
+            <a:schemeClr val="accent1"/>
+          </a:effectRef>
+          <a:fontRef idx="minor">
+            <a:schemeClr val="lt1"/>
+          </a:fontRef>
+        </p:style>
+        <p:txBody>
+          <a:bodyPr rtlCol="0" anchor="ctr"/>
+          <a:lstStyle/>
+          <a:p>
+            <a:pPr algn="ctr"/>
+          </a:p>
+        </p:txBody>
+      </p:sp>
+      <p:sp>
+        <p:nvSpPr>
+          <p:cNvPr id="75" name="TextBox 74"/>
+          <p:cNvSpPr txBox="1"/>
+          <p:nvPr/>
+        </p:nvSpPr>
+        <p:spPr>
+          <a:xfrm>
+            <a:off x="11567160" y="5824727"/>
+            <a:ext cx="5779008" cy="731520"/>
+          </a:xfrm>
+          <a:prstGeom prst="rect">
+            <a:avLst/>
+          </a:prstGeom>
+          <a:noFill/>
+        </p:spPr>
+        <p:txBody>
+          <a:bodyPr wrap="square" anchor="ctr" lIns="0" rIns="0" tIns="0" bIns="0">
+            <a:spAutoFit/>
+          </a:bodyPr>
+          <a:lstStyle/>
+          <a:p>
+            <a:pPr algn="l"/>
+            <a:r>
+              <a:rPr sz="1450" b="0" i="0">
+                <a:solidFill>
+                  <a:srgbClr val="1F2A44"/>
+                </a:solidFill>
+                <a:latin typeface="Exo 2"/>
+                <a:ea typeface="Exo 2"/>
+                <a:cs typeface="Exo 2"/>
+              </a:rPr>
+              <a:t>Pilot: 266K views, 22,580 clicks, 6 new accounts for USD 600</a:t>
+            </a:r>
+          </a:p>
+        </p:txBody>
+      </p:sp>
+      <p:sp>
+        <p:nvSpPr>
+          <p:cNvPr id="76" name="Rectangle 75"/>
+          <p:cNvSpPr/>
+          <p:nvPr/>
+        </p:nvSpPr>
+        <p:spPr>
+          <a:xfrm>
+            <a:off x="841248" y="6556247"/>
+            <a:ext cx="3291840" cy="731520"/>
+          </a:xfrm>
+          <a:prstGeom prst="rect">
+            <a:avLst/>
+          </a:prstGeom>
+          <a:solidFill>
+            <a:srgbClr val="EEF1F8"/>
+          </a:solidFill>
+          <a:ln w="9525">
+            <a:solidFill>
+              <a:srgbClr val="D9DFEA"/>
+            </a:solidFill>
+          </a:ln>
+          <a:effectLst/>
+        </p:spPr>
+        <p:style>
+          <a:lnRef idx="1">
+            <a:schemeClr val="accent1"/>
+          </a:lnRef>
+          <a:fillRef idx="3">
+            <a:schemeClr val="accent1"/>
+          </a:fillRef>
+          <a:effectRef idx="2">
+            <a:schemeClr val="accent1"/>
+          </a:effectRef>
+          <a:fontRef idx="minor">
+            <a:schemeClr val="lt1"/>
+          </a:fontRef>
+        </p:style>
+        <p:txBody>
+          <a:bodyPr rtlCol="0" anchor="ctr"/>
+          <a:lstStyle/>
+          <a:p>
+            <a:pPr algn="ctr"/>
+          </a:p>
+        </p:txBody>
+      </p:sp>
+      <p:sp>
+        <p:nvSpPr>
+          <p:cNvPr id="77" name="TextBox 76"/>
+          <p:cNvSpPr txBox="1"/>
+          <p:nvPr/>
+        </p:nvSpPr>
+        <p:spPr>
+          <a:xfrm>
+            <a:off x="1005840" y="6556247"/>
+            <a:ext cx="3017520" cy="731520"/>
+          </a:xfrm>
+          <a:prstGeom prst="rect">
+            <a:avLst/>
+          </a:prstGeom>
+          <a:noFill/>
+        </p:spPr>
+        <p:txBody>
+          <a:bodyPr wrap="square" anchor="ctr" lIns="0" rIns="0" tIns="0" bIns="0">
+            <a:spAutoFit/>
+          </a:bodyPr>
+          <a:lstStyle/>
+          <a:p>
+            <a:pPr algn="l"/>
+            <a:r>
+              <a:rPr sz="1550" b="1" i="0">
+                <a:solidFill>
+                  <a:srgbClr val="132257"/>
+                </a:solidFill>
+                <a:latin typeface="Exo 2 Bold"/>
+                <a:ea typeface="Exo 2 Bold"/>
+                <a:cs typeface="Exo 2 Bold"/>
+              </a:rPr>
+              <a:t>Creator videos</a:t>
+            </a:r>
+          </a:p>
+        </p:txBody>
+      </p:sp>
+      <p:sp>
+        <p:nvSpPr>
+          <p:cNvPr id="78" name="Rectangle 77"/>
+          <p:cNvSpPr/>
+          <p:nvPr/>
+        </p:nvSpPr>
+        <p:spPr>
+          <a:xfrm>
+            <a:off x="4133088" y="6556247"/>
+            <a:ext cx="2743200" cy="731520"/>
+          </a:xfrm>
+          <a:prstGeom prst="rect">
+            <a:avLst/>
+          </a:prstGeom>
+          <a:solidFill>
+            <a:srgbClr val="EEF1F8"/>
+          </a:solidFill>
+          <a:ln w="9525">
+            <a:solidFill>
+              <a:srgbClr val="D9DFEA"/>
+            </a:solidFill>
+          </a:ln>
+          <a:effectLst/>
+        </p:spPr>
+        <p:style>
+          <a:lnRef idx="1">
+            <a:schemeClr val="accent1"/>
+          </a:lnRef>
+          <a:fillRef idx="3">
+            <a:schemeClr val="accent1"/>
+          </a:fillRef>
+          <a:effectRef idx="2">
+            <a:schemeClr val="accent1"/>
+          </a:effectRef>
+          <a:fontRef idx="minor">
+            <a:schemeClr val="lt1"/>
+          </a:fontRef>
+        </p:style>
+        <p:txBody>
+          <a:bodyPr rtlCol="0" anchor="ctr"/>
+          <a:lstStyle/>
+          <a:p>
+            <a:pPr algn="ctr"/>
+          </a:p>
+        </p:txBody>
+      </p:sp>
+      <p:sp>
+        <p:nvSpPr>
+          <p:cNvPr id="79" name="TextBox 78"/>
+          <p:cNvSpPr txBox="1"/>
+          <p:nvPr/>
+        </p:nvSpPr>
+        <p:spPr>
+          <a:xfrm>
+            <a:off x="4297680" y="6556247"/>
+            <a:ext cx="2468880" cy="731520"/>
+          </a:xfrm>
+          <a:prstGeom prst="rect">
+            <a:avLst/>
+          </a:prstGeom>
+          <a:noFill/>
+        </p:spPr>
+        <p:txBody>
+          <a:bodyPr wrap="square" anchor="ctr" lIns="0" rIns="0" tIns="0" bIns="0">
+            <a:spAutoFit/>
+          </a:bodyPr>
+          <a:lstStyle/>
+          <a:p>
+            <a:pPr algn="l"/>
+            <a:r>
+              <a:rPr sz="1550" b="0" i="0">
+                <a:solidFill>
+                  <a:srgbClr val="1F2A44"/>
+                </a:solidFill>
+                <a:latin typeface="Exo 2"/>
+                <a:ea typeface="Exo 2"/>
+                <a:cs typeface="Exo 2"/>
+              </a:rPr>
+              <a:t>Instagram</a:t>
+            </a:r>
+          </a:p>
+        </p:txBody>
+      </p:sp>
+      <p:sp>
+        <p:nvSpPr>
+          <p:cNvPr id="80" name="Rectangle 79"/>
+          <p:cNvSpPr/>
+          <p:nvPr/>
+        </p:nvSpPr>
+        <p:spPr>
+          <a:xfrm>
+            <a:off x="6876288" y="6556247"/>
+            <a:ext cx="2377440" cy="731520"/>
+          </a:xfrm>
+          <a:prstGeom prst="rect">
+            <a:avLst/>
+          </a:prstGeom>
+          <a:solidFill>
+            <a:srgbClr val="EEF1F8"/>
+          </a:solidFill>
+          <a:ln w="9525">
+            <a:solidFill>
+              <a:srgbClr val="D9DFEA"/>
+            </a:solidFill>
+          </a:ln>
+          <a:effectLst/>
+        </p:spPr>
+        <p:style>
+          <a:lnRef idx="1">
+            <a:schemeClr val="accent1"/>
+          </a:lnRef>
+          <a:fillRef idx="3">
+            <a:schemeClr val="accent1"/>
+          </a:fillRef>
+          <a:effectRef idx="2">
+            <a:schemeClr val="accent1"/>
+          </a:effectRef>
+          <a:fontRef idx="minor">
+            <a:schemeClr val="lt1"/>
+          </a:fontRef>
+        </p:style>
+        <p:txBody>
+          <a:bodyPr rtlCol="0" anchor="ctr"/>
+          <a:lstStyle/>
+          <a:p>
+            <a:pPr algn="ctr"/>
+          </a:p>
+        </p:txBody>
+      </p:sp>
+      <p:sp>
+        <p:nvSpPr>
+          <p:cNvPr id="81" name="TextBox 80"/>
+          <p:cNvSpPr txBox="1"/>
+          <p:nvPr/>
+        </p:nvSpPr>
+        <p:spPr>
+          <a:xfrm>
+            <a:off x="7040880" y="6556247"/>
+            <a:ext cx="2103120" cy="731520"/>
+          </a:xfrm>
+          <a:prstGeom prst="rect">
+            <a:avLst/>
+          </a:prstGeom>
+          <a:noFill/>
+        </p:spPr>
+        <p:txBody>
+          <a:bodyPr wrap="square" anchor="ctr" lIns="0" rIns="0" tIns="0" bIns="0">
+            <a:spAutoFit/>
+          </a:bodyPr>
+          <a:lstStyle/>
+          <a:p>
+            <a:pPr algn="l"/>
+            <a:r>
+              <a:rPr sz="1550" b="0" i="0">
+                <a:solidFill>
+                  <a:srgbClr val="1F2A44"/>
+                </a:solidFill>
+                <a:latin typeface="Exo 2"/>
+                <a:ea typeface="Exo 2"/>
+                <a:cs typeface="Exo 2"/>
+              </a:rPr>
+              <a:t>Jul to Oct</a:t>
+            </a:r>
+          </a:p>
+        </p:txBody>
+      </p:sp>
+      <p:sp>
+        <p:nvSpPr>
+          <p:cNvPr id="82" name="Rectangle 81"/>
+          <p:cNvSpPr/>
+          <p:nvPr/>
+        </p:nvSpPr>
+        <p:spPr>
+          <a:xfrm>
+            <a:off x="9253728" y="6556247"/>
+            <a:ext cx="2148840" cy="731520"/>
+          </a:xfrm>
+          <a:prstGeom prst="rect">
+            <a:avLst/>
+          </a:prstGeom>
+          <a:solidFill>
+            <a:srgbClr val="EEF1F8"/>
+          </a:solidFill>
+          <a:ln w="9525">
+            <a:solidFill>
+              <a:srgbClr val="D9DFEA"/>
+            </a:solidFill>
+          </a:ln>
+          <a:effectLst/>
+        </p:spPr>
+        <p:style>
+          <a:lnRef idx="1">
+            <a:schemeClr val="accent1"/>
+          </a:lnRef>
+          <a:fillRef idx="3">
+            <a:schemeClr val="accent1"/>
+          </a:fillRef>
+          <a:effectRef idx="2">
+            <a:schemeClr val="accent1"/>
+          </a:effectRef>
+          <a:fontRef idx="minor">
+            <a:schemeClr val="lt1"/>
+          </a:fontRef>
+        </p:style>
+        <p:txBody>
+          <a:bodyPr rtlCol="0" anchor="ctr"/>
+          <a:lstStyle/>
+          <a:p>
+            <a:pPr algn="ctr"/>
+          </a:p>
+        </p:txBody>
+      </p:sp>
+      <p:sp>
+        <p:nvSpPr>
+          <p:cNvPr id="83" name="TextBox 82"/>
+          <p:cNvSpPr txBox="1"/>
+          <p:nvPr/>
+        </p:nvSpPr>
+        <p:spPr>
+          <a:xfrm>
+            <a:off x="9418320" y="6556247"/>
+            <a:ext cx="1874520" cy="731520"/>
+          </a:xfrm>
+          <a:prstGeom prst="rect">
+            <a:avLst/>
+          </a:prstGeom>
+          <a:noFill/>
+        </p:spPr>
+        <p:txBody>
+          <a:bodyPr wrap="square" anchor="ctr" lIns="0" rIns="0" tIns="0" bIns="0">
+            <a:spAutoFit/>
+          </a:bodyPr>
+          <a:lstStyle/>
+          <a:p>
+            <a:pPr algn="l"/>
+            <a:r>
+              <a:rPr sz="1550" b="1" i="0">
+                <a:solidFill>
+                  <a:srgbClr val="132257"/>
+                </a:solidFill>
+                <a:latin typeface="Exo 2 Bold"/>
+                <a:ea typeface="Exo 2 Bold"/>
+                <a:cs typeface="Exo 2 Bold"/>
+              </a:rPr>
+              <a:t>9,037</a:t>
+            </a:r>
+          </a:p>
+        </p:txBody>
+      </p:sp>
+      <p:sp>
+        <p:nvSpPr>
+          <p:cNvPr id="84" name="Rectangle 83"/>
+          <p:cNvSpPr/>
+          <p:nvPr/>
+        </p:nvSpPr>
+        <p:spPr>
+          <a:xfrm>
+            <a:off x="11402568" y="6556247"/>
+            <a:ext cx="6053328" cy="731520"/>
+          </a:xfrm>
+          <a:prstGeom prst="rect">
+            <a:avLst/>
+          </a:prstGeom>
+          <a:solidFill>
+            <a:srgbClr val="EEF1F8"/>
+          </a:solidFill>
+          <a:ln w="9525">
+            <a:solidFill>
+              <a:srgbClr val="D9DFEA"/>
+            </a:solidFill>
+          </a:ln>
+          <a:effectLst/>
+        </p:spPr>
+        <p:style>
+          <a:lnRef idx="1">
+            <a:schemeClr val="accent1"/>
+          </a:lnRef>
+          <a:fillRef idx="3">
+            <a:schemeClr val="accent1"/>
+          </a:fillRef>
+          <a:effectRef idx="2">
+            <a:schemeClr val="accent1"/>
+          </a:effectRef>
+          <a:fontRef idx="minor">
+            <a:schemeClr val="lt1"/>
+          </a:fontRef>
+        </p:style>
+        <p:txBody>
+          <a:bodyPr rtlCol="0" anchor="ctr"/>
+          <a:lstStyle/>
+          <a:p>
+            <a:pPr algn="ctr"/>
+          </a:p>
+        </p:txBody>
+      </p:sp>
+      <p:sp>
+        <p:nvSpPr>
+          <p:cNvPr id="85" name="TextBox 84"/>
+          <p:cNvSpPr txBox="1"/>
+          <p:nvPr/>
+        </p:nvSpPr>
+        <p:spPr>
+          <a:xfrm>
+            <a:off x="11567160" y="6556247"/>
+            <a:ext cx="5779008" cy="731520"/>
+          </a:xfrm>
+          <a:prstGeom prst="rect">
+            <a:avLst/>
+          </a:prstGeom>
+          <a:noFill/>
+        </p:spPr>
+        <p:txBody>
+          <a:bodyPr wrap="square" anchor="ctr" lIns="0" rIns="0" tIns="0" bIns="0">
+            <a:spAutoFit/>
+          </a:bodyPr>
+          <a:lstStyle/>
+          <a:p>
+            <a:pPr algn="l"/>
+            <a:r>
+              <a:rPr sz="1450" b="0" i="0">
+                <a:solidFill>
+                  <a:srgbClr val="1F2A44"/>
+                </a:solidFill>
+                <a:latin typeface="Exo 2"/>
+                <a:ea typeface="Exo 2"/>
+                <a:cs typeface="Exo 2"/>
+              </a:rPr>
+              <a:t>Musheera 5.3M and Ali Sabeel 1.3M views; Abdulelah in October</a:t>
+            </a:r>
+          </a:p>
+        </p:txBody>
+      </p:sp>
+      <p:sp>
+        <p:nvSpPr>
+          <p:cNvPr id="86" name="Rectangle 85"/>
+          <p:cNvSpPr/>
+          <p:nvPr/>
+        </p:nvSpPr>
+        <p:spPr>
+          <a:xfrm>
+            <a:off x="841248" y="7287767"/>
+            <a:ext cx="3291840" cy="731520"/>
+          </a:xfrm>
+          <a:prstGeom prst="rect">
+            <a:avLst/>
+          </a:prstGeom>
+          <a:solidFill>
+            <a:srgbClr val="FFFFFF"/>
+          </a:solidFill>
+          <a:ln w="9525">
+            <a:solidFill>
+              <a:srgbClr val="D9DFEA"/>
+            </a:solidFill>
+          </a:ln>
+          <a:effectLst/>
+        </p:spPr>
+        <p:style>
+          <a:lnRef idx="1">
+            <a:schemeClr val="accent1"/>
+          </a:lnRef>
+          <a:fillRef idx="3">
+            <a:schemeClr val="accent1"/>
+          </a:fillRef>
+          <a:effectRef idx="2">
+            <a:schemeClr val="accent1"/>
+          </a:effectRef>
+          <a:fontRef idx="minor">
+            <a:schemeClr val="lt1"/>
+          </a:fontRef>
+        </p:style>
+        <p:txBody>
+          <a:bodyPr rtlCol="0" anchor="ctr"/>
+          <a:lstStyle/>
+          <a:p>
+            <a:pPr algn="ctr"/>
+          </a:p>
+        </p:txBody>
+      </p:sp>
+      <p:sp>
+        <p:nvSpPr>
+          <p:cNvPr id="87" name="TextBox 86"/>
+          <p:cNvSpPr txBox="1"/>
+          <p:nvPr/>
+        </p:nvSpPr>
+        <p:spPr>
+          <a:xfrm>
+            <a:off x="1005840" y="7287767"/>
+            <a:ext cx="3017520" cy="731520"/>
+          </a:xfrm>
+          <a:prstGeom prst="rect">
+            <a:avLst/>
+          </a:prstGeom>
+          <a:noFill/>
+        </p:spPr>
+        <p:txBody>
+          <a:bodyPr wrap="square" anchor="ctr" lIns="0" rIns="0" tIns="0" bIns="0">
+            <a:spAutoFit/>
+          </a:bodyPr>
+          <a:lstStyle/>
+          <a:p>
+            <a:pPr algn="l"/>
+            <a:r>
+              <a:rPr sz="1550" b="1" i="0">
+                <a:solidFill>
+                  <a:srgbClr val="132257"/>
+                </a:solidFill>
+                <a:latin typeface="Exo 2 Bold"/>
+                <a:ea typeface="Exo 2 Bold"/>
+                <a:cs typeface="Exo 2 Bold"/>
+              </a:rPr>
+              <a:t>USD 5,000 Prize Campaign</a:t>
+            </a:r>
+          </a:p>
+        </p:txBody>
+      </p:sp>
+      <p:sp>
+        <p:nvSpPr>
+          <p:cNvPr id="88" name="Rectangle 87"/>
+          <p:cNvSpPr/>
+          <p:nvPr/>
+        </p:nvSpPr>
+        <p:spPr>
+          <a:xfrm>
+            <a:off x="4133088" y="7287767"/>
+            <a:ext cx="2743200" cy="731520"/>
+          </a:xfrm>
+          <a:prstGeom prst="rect">
+            <a:avLst/>
+          </a:prstGeom>
+          <a:solidFill>
+            <a:srgbClr val="FFFFFF"/>
+          </a:solidFill>
+          <a:ln w="9525">
+            <a:solidFill>
+              <a:srgbClr val="D9DFEA"/>
+            </a:solidFill>
+          </a:ln>
+          <a:effectLst/>
+        </p:spPr>
+        <p:style>
+          <a:lnRef idx="1">
+            <a:schemeClr val="accent1"/>
+          </a:lnRef>
+          <a:fillRef idx="3">
+            <a:schemeClr val="accent1"/>
+          </a:fillRef>
+          <a:effectRef idx="2">
+            <a:schemeClr val="accent1"/>
+          </a:effectRef>
+          <a:fontRef idx="minor">
+            <a:schemeClr val="lt1"/>
+          </a:fontRef>
+        </p:style>
+        <p:txBody>
+          <a:bodyPr rtlCol="0" anchor="ctr"/>
+          <a:lstStyle/>
+          <a:p>
+            <a:pPr algn="ctr"/>
+          </a:p>
+        </p:txBody>
+      </p:sp>
+      <p:sp>
+        <p:nvSpPr>
+          <p:cNvPr id="89" name="TextBox 88"/>
+          <p:cNvSpPr txBox="1"/>
+          <p:nvPr/>
+        </p:nvSpPr>
+        <p:spPr>
+          <a:xfrm>
+            <a:off x="4297680" y="7287767"/>
+            <a:ext cx="2468880" cy="731520"/>
+          </a:xfrm>
+          <a:prstGeom prst="rect">
+            <a:avLst/>
+          </a:prstGeom>
+          <a:noFill/>
+        </p:spPr>
+        <p:txBody>
+          <a:bodyPr wrap="square" anchor="ctr" lIns="0" rIns="0" tIns="0" bIns="0">
+            <a:spAutoFit/>
+          </a:bodyPr>
+          <a:lstStyle/>
+          <a:p>
+            <a:pPr algn="l"/>
+            <a:r>
+              <a:rPr sz="1550" b="0" i="0">
+                <a:solidFill>
+                  <a:srgbClr val="1F2A44"/>
+                </a:solidFill>
+                <a:latin typeface="Exo 2"/>
+                <a:ea typeface="Exo 2"/>
+                <a:cs typeface="Exo 2"/>
+              </a:rPr>
+              <a:t>Instagram, landing pages</a:t>
+            </a:r>
+          </a:p>
+        </p:txBody>
+      </p:sp>
+      <p:sp>
+        <p:nvSpPr>
+          <p:cNvPr id="90" name="Rectangle 89"/>
+          <p:cNvSpPr/>
+          <p:nvPr/>
+        </p:nvSpPr>
+        <p:spPr>
+          <a:xfrm>
+            <a:off x="6876288" y="7287767"/>
+            <a:ext cx="2377440" cy="731520"/>
+          </a:xfrm>
+          <a:prstGeom prst="rect">
+            <a:avLst/>
+          </a:prstGeom>
+          <a:solidFill>
+            <a:srgbClr val="FFFFFF"/>
+          </a:solidFill>
+          <a:ln w="9525">
+            <a:solidFill>
+              <a:srgbClr val="D9DFEA"/>
+            </a:solidFill>
+          </a:ln>
+          <a:effectLst/>
+        </p:spPr>
+        <p:style>
+          <a:lnRef idx="1">
+            <a:schemeClr val="accent1"/>
+          </a:lnRef>
+          <a:fillRef idx="3">
+            <a:schemeClr val="accent1"/>
+          </a:fillRef>
+          <a:effectRef idx="2">
+            <a:schemeClr val="accent1"/>
+          </a:effectRef>
+          <a:fontRef idx="minor">
+            <a:schemeClr val="lt1"/>
+          </a:fontRef>
+        </p:style>
+        <p:txBody>
+          <a:bodyPr rtlCol="0" anchor="ctr"/>
+          <a:lstStyle/>
+          <a:p>
+            <a:pPr algn="ctr"/>
+          </a:p>
+        </p:txBody>
+      </p:sp>
+      <p:sp>
+        <p:nvSpPr>
+          <p:cNvPr id="91" name="TextBox 90"/>
+          <p:cNvSpPr txBox="1"/>
+          <p:nvPr/>
+        </p:nvSpPr>
+        <p:spPr>
+          <a:xfrm>
+            <a:off x="7040880" y="7287767"/>
+            <a:ext cx="2103120" cy="731520"/>
+          </a:xfrm>
+          <a:prstGeom prst="rect">
+            <a:avLst/>
+          </a:prstGeom>
+          <a:noFill/>
+        </p:spPr>
+        <p:txBody>
+          <a:bodyPr wrap="square" anchor="ctr" lIns="0" rIns="0" tIns="0" bIns="0">
+            <a:spAutoFit/>
+          </a:bodyPr>
+          <a:lstStyle/>
+          <a:p>
+            <a:pPr algn="l"/>
+            <a:r>
+              <a:rPr sz="1550" b="0" i="0">
+                <a:solidFill>
+                  <a:srgbClr val="1F2A44"/>
+                </a:solidFill>
+                <a:latin typeface="Exo 2"/>
+                <a:ea typeface="Exo 2"/>
+                <a:cs typeface="Exo 2"/>
+              </a:rPr>
+              <a:t>1 Aug to 31 Dec</a:t>
+            </a:r>
+          </a:p>
+        </p:txBody>
+      </p:sp>
+      <p:sp>
+        <p:nvSpPr>
+          <p:cNvPr id="92" name="Rectangle 91"/>
+          <p:cNvSpPr/>
+          <p:nvPr/>
+        </p:nvSpPr>
+        <p:spPr>
+          <a:xfrm>
+            <a:off x="9253728" y="7287767"/>
+            <a:ext cx="2148840" cy="731520"/>
+          </a:xfrm>
+          <a:prstGeom prst="rect">
+            <a:avLst/>
+          </a:prstGeom>
+          <a:solidFill>
+            <a:srgbClr val="FFFFFF"/>
+          </a:solidFill>
+          <a:ln w="9525">
+            <a:solidFill>
+              <a:srgbClr val="D9DFEA"/>
+            </a:solidFill>
+          </a:ln>
+          <a:effectLst/>
+        </p:spPr>
+        <p:style>
+          <a:lnRef idx="1">
+            <a:schemeClr val="accent1"/>
+          </a:lnRef>
+          <a:fillRef idx="3">
+            <a:schemeClr val="accent1"/>
+          </a:fillRef>
+          <a:effectRef idx="2">
+            <a:schemeClr val="accent1"/>
+          </a:effectRef>
+          <a:fontRef idx="minor">
+            <a:schemeClr val="lt1"/>
+          </a:fontRef>
+        </p:style>
+        <p:txBody>
+          <a:bodyPr rtlCol="0" anchor="ctr"/>
+          <a:lstStyle/>
+          <a:p>
+            <a:pPr algn="ctr"/>
+          </a:p>
+        </p:txBody>
+      </p:sp>
+      <p:sp>
+        <p:nvSpPr>
+          <p:cNvPr id="93" name="TextBox 92"/>
+          <p:cNvSpPr txBox="1"/>
+          <p:nvPr/>
+        </p:nvSpPr>
+        <p:spPr>
+          <a:xfrm>
+            <a:off x="9418320" y="7287767"/>
+            <a:ext cx="1874520" cy="731520"/>
+          </a:xfrm>
+          <a:prstGeom prst="rect">
+            <a:avLst/>
+          </a:prstGeom>
+          <a:noFill/>
+        </p:spPr>
+        <p:txBody>
+          <a:bodyPr wrap="square" anchor="ctr" lIns="0" rIns="0" tIns="0" bIns="0">
+            <a:spAutoFit/>
+          </a:bodyPr>
+          <a:lstStyle/>
+          <a:p>
+            <a:pPr algn="l"/>
+            <a:r>
+              <a:rPr sz="1550" b="1" i="0">
+                <a:solidFill>
+                  <a:srgbClr val="132257"/>
+                </a:solidFill>
+                <a:latin typeface="Exo 2 Bold"/>
+                <a:ea typeface="Exo 2 Bold"/>
+                <a:cs typeface="Exo 2 Bold"/>
+              </a:rPr>
+              <a:t>Prizes up to 5,000</a:t>
+            </a:r>
+          </a:p>
+        </p:txBody>
+      </p:sp>
+      <p:sp>
+        <p:nvSpPr>
+          <p:cNvPr id="94" name="Rectangle 93"/>
+          <p:cNvSpPr/>
+          <p:nvPr/>
+        </p:nvSpPr>
+        <p:spPr>
+          <a:xfrm>
+            <a:off x="11402568" y="7287767"/>
+            <a:ext cx="6053328" cy="731520"/>
+          </a:xfrm>
+          <a:prstGeom prst="rect">
+            <a:avLst/>
+          </a:prstGeom>
+          <a:solidFill>
+            <a:srgbClr val="FFFFFF"/>
+          </a:solidFill>
+          <a:ln w="9525">
+            <a:solidFill>
+              <a:srgbClr val="D9DFEA"/>
+            </a:solidFill>
+          </a:ln>
+          <a:effectLst/>
+        </p:spPr>
+        <p:style>
+          <a:lnRef idx="1">
+            <a:schemeClr val="accent1"/>
+          </a:lnRef>
+          <a:fillRef idx="3">
+            <a:schemeClr val="accent1"/>
+          </a:fillRef>
+          <a:effectRef idx="2">
+            <a:schemeClr val="accent1"/>
+          </a:effectRef>
+          <a:fontRef idx="minor">
+            <a:schemeClr val="lt1"/>
+          </a:fontRef>
+        </p:style>
+        <p:txBody>
+          <a:bodyPr rtlCol="0" anchor="ctr"/>
+          <a:lstStyle/>
+          <a:p>
+            <a:pPr algn="ctr"/>
+          </a:p>
+        </p:txBody>
+      </p:sp>
+      <p:sp>
+        <p:nvSpPr>
+          <p:cNvPr id="95" name="TextBox 94"/>
+          <p:cNvSpPr txBox="1"/>
+          <p:nvPr/>
+        </p:nvSpPr>
+        <p:spPr>
+          <a:xfrm>
+            <a:off x="11567160" y="7287767"/>
+            <a:ext cx="5779008" cy="731520"/>
+          </a:xfrm>
+          <a:prstGeom prst="rect">
+            <a:avLst/>
+          </a:prstGeom>
+          <a:noFill/>
+        </p:spPr>
+        <p:txBody>
+          <a:bodyPr wrap="square" anchor="ctr" lIns="0" rIns="0" tIns="0" bIns="0">
+            <a:spAutoFit/>
+          </a:bodyPr>
+          <a:lstStyle/>
+          <a:p>
+            <a:pPr algn="l"/>
+            <a:r>
+              <a:rPr sz="1450" b="0" i="0">
+                <a:solidFill>
+                  <a:srgbClr val="1F2A44"/>
+                </a:solidFill>
+                <a:latin typeface="Exo 2"/>
+                <a:ea typeface="Exo 2"/>
+                <a:cs typeface="Exo 2"/>
+              </a:rPr>
+              <a:t>Live; draw on 10 Jan 2027</a:t>
+            </a:r>
+          </a:p>
+        </p:txBody>
+      </p:sp>
+      <p:sp>
+        <p:nvSpPr>
+          <p:cNvPr id="96" name="Rectangle 95"/>
+          <p:cNvSpPr/>
+          <p:nvPr/>
+        </p:nvSpPr>
+        <p:spPr>
+          <a:xfrm>
+            <a:off x="841248" y="8019288"/>
+            <a:ext cx="3291840" cy="731520"/>
+          </a:xfrm>
+          <a:prstGeom prst="rect">
+            <a:avLst/>
+          </a:prstGeom>
+          <a:solidFill>
+            <a:srgbClr val="EEF1F8"/>
+          </a:solidFill>
+          <a:ln w="9525">
+            <a:solidFill>
+              <a:srgbClr val="D9DFEA"/>
+            </a:solidFill>
+          </a:ln>
+          <a:effectLst/>
+        </p:spPr>
+        <p:style>
+          <a:lnRef idx="1">
+            <a:schemeClr val="accent1"/>
+          </a:lnRef>
+          <a:fillRef idx="3">
+            <a:schemeClr val="accent1"/>
+          </a:fillRef>
+          <a:effectRef idx="2">
+            <a:schemeClr val="accent1"/>
+          </a:effectRef>
+          <a:fontRef idx="minor">
+            <a:schemeClr val="lt1"/>
+          </a:fontRef>
+        </p:style>
+        <p:txBody>
+          <a:bodyPr rtlCol="0" anchor="ctr"/>
+          <a:lstStyle/>
+          <a:p>
+            <a:pPr algn="ctr"/>
+          </a:p>
+        </p:txBody>
+      </p:sp>
+      <p:sp>
+        <p:nvSpPr>
+          <p:cNvPr id="97" name="TextBox 96"/>
+          <p:cNvSpPr txBox="1"/>
+          <p:nvPr/>
+        </p:nvSpPr>
+        <p:spPr>
+          <a:xfrm>
+            <a:off x="1005840" y="8019288"/>
+            <a:ext cx="3017520" cy="731520"/>
+          </a:xfrm>
+          <a:prstGeom prst="rect">
+            <a:avLst/>
+          </a:prstGeom>
+          <a:noFill/>
+        </p:spPr>
+        <p:txBody>
+          <a:bodyPr wrap="square" anchor="ctr" lIns="0" rIns="0" tIns="0" bIns="0">
+            <a:spAutoFit/>
+          </a:bodyPr>
+          <a:lstStyle/>
+          <a:p>
+            <a:pPr algn="l"/>
+            <a:r>
+              <a:rPr sz="1550" b="1" i="0">
+                <a:solidFill>
+                  <a:srgbClr val="132257"/>
+                </a:solidFill>
+                <a:latin typeface="Exo 2 Bold"/>
+                <a:ea typeface="Exo 2 Bold"/>
+                <a:cs typeface="Exo 2 Bold"/>
+              </a:rPr>
+              <a:t>Google Ads and LinkedIn</a:t>
+            </a:r>
+          </a:p>
+        </p:txBody>
+      </p:sp>
+      <p:sp>
+        <p:nvSpPr>
+          <p:cNvPr id="98" name="Rectangle 97"/>
+          <p:cNvSpPr/>
+          <p:nvPr/>
+        </p:nvSpPr>
+        <p:spPr>
+          <a:xfrm>
+            <a:off x="4133088" y="8019288"/>
+            <a:ext cx="2743200" cy="731520"/>
+          </a:xfrm>
+          <a:prstGeom prst="rect">
+            <a:avLst/>
+          </a:prstGeom>
+          <a:solidFill>
+            <a:srgbClr val="EEF1F8"/>
+          </a:solidFill>
+          <a:ln w="9525">
+            <a:solidFill>
+              <a:srgbClr val="D9DFEA"/>
+            </a:solidFill>
+          </a:ln>
+          <a:effectLst/>
+        </p:spPr>
+        <p:style>
+          <a:lnRef idx="1">
+            <a:schemeClr val="accent1"/>
+          </a:lnRef>
+          <a:fillRef idx="3">
+            <a:schemeClr val="accent1"/>
+          </a:fillRef>
+          <a:effectRef idx="2">
+            <a:schemeClr val="accent1"/>
+          </a:effectRef>
+          <a:fontRef idx="minor">
+            <a:schemeClr val="lt1"/>
+          </a:fontRef>
+        </p:style>
+        <p:txBody>
+          <a:bodyPr rtlCol="0" anchor="ctr"/>
+          <a:lstStyle/>
+          <a:p>
+            <a:pPr algn="ctr"/>
+          </a:p>
+        </p:txBody>
+      </p:sp>
+      <p:sp>
+        <p:nvSpPr>
+          <p:cNvPr id="99" name="TextBox 98"/>
+          <p:cNvSpPr txBox="1"/>
+          <p:nvPr/>
+        </p:nvSpPr>
+        <p:spPr>
+          <a:xfrm>
+            <a:off x="4297680" y="8019288"/>
+            <a:ext cx="2468880" cy="731520"/>
+          </a:xfrm>
+          <a:prstGeom prst="rect">
+            <a:avLst/>
+          </a:prstGeom>
+          <a:noFill/>
+        </p:spPr>
+        <p:txBody>
+          <a:bodyPr wrap="square" anchor="ctr" lIns="0" rIns="0" tIns="0" bIns="0">
+            <a:spAutoFit/>
+          </a:bodyPr>
+          <a:lstStyle/>
+          <a:p>
+            <a:pPr algn="l"/>
+            <a:r>
+              <a:rPr sz="1550" b="0" i="0">
+                <a:solidFill>
+                  <a:srgbClr val="1F2A44"/>
+                </a:solidFill>
+                <a:latin typeface="Exo 2"/>
+                <a:ea typeface="Exo 2"/>
+                <a:cs typeface="Exo 2"/>
+              </a:rPr>
+              <a:t>Saudi, then GCC</a:t>
+            </a:r>
+          </a:p>
+        </p:txBody>
+      </p:sp>
+      <p:sp>
+        <p:nvSpPr>
+          <p:cNvPr id="100" name="Rectangle 99"/>
+          <p:cNvSpPr/>
+          <p:nvPr/>
+        </p:nvSpPr>
+        <p:spPr>
+          <a:xfrm>
+            <a:off x="6876288" y="8019288"/>
+            <a:ext cx="2377440" cy="731520"/>
+          </a:xfrm>
+          <a:prstGeom prst="rect">
+            <a:avLst/>
+          </a:prstGeom>
+          <a:solidFill>
+            <a:srgbClr val="EEF1F8"/>
+          </a:solidFill>
+          <a:ln w="9525">
+            <a:solidFill>
+              <a:srgbClr val="D9DFEA"/>
+            </a:solidFill>
+          </a:ln>
+          <a:effectLst/>
+        </p:spPr>
+        <p:style>
+          <a:lnRef idx="1">
+            <a:schemeClr val="accent1"/>
+          </a:lnRef>
+          <a:fillRef idx="3">
+            <a:schemeClr val="accent1"/>
+          </a:fillRef>
+          <a:effectRef idx="2">
+            <a:schemeClr val="accent1"/>
+          </a:effectRef>
+          <a:fontRef idx="minor">
+            <a:schemeClr val="lt1"/>
+          </a:fontRef>
+        </p:style>
+        <p:txBody>
+          <a:bodyPr rtlCol="0" anchor="ctr"/>
+          <a:lstStyle/>
+          <a:p>
+            <a:pPr algn="ctr"/>
+          </a:p>
+        </p:txBody>
+      </p:sp>
+      <p:sp>
+        <p:nvSpPr>
+          <p:cNvPr id="101" name="TextBox 100"/>
+          <p:cNvSpPr txBox="1"/>
+          <p:nvPr/>
+        </p:nvSpPr>
+        <p:spPr>
+          <a:xfrm>
+            <a:off x="7040880" y="8019288"/>
+            <a:ext cx="2103120" cy="731520"/>
+          </a:xfrm>
+          <a:prstGeom prst="rect">
+            <a:avLst/>
+          </a:prstGeom>
+          <a:noFill/>
+        </p:spPr>
+        <p:txBody>
+          <a:bodyPr wrap="square" anchor="ctr" lIns="0" rIns="0" tIns="0" bIns="0">
+            <a:spAutoFit/>
+          </a:bodyPr>
+          <a:lstStyle/>
+          <a:p>
+            <a:pPr algn="l"/>
+            <a:r>
+              <a:rPr sz="1550" b="0" i="0">
+                <a:solidFill>
+                  <a:srgbClr val="1F2A44"/>
+                </a:solidFill>
+                <a:latin typeface="Exo 2"/>
+                <a:ea typeface="Exo 2"/>
+                <a:cs typeface="Exo 2"/>
+              </a:rPr>
+              <a:t>From 22 Sep</a:t>
+            </a:r>
+          </a:p>
+        </p:txBody>
+      </p:sp>
+      <p:sp>
+        <p:nvSpPr>
+          <p:cNvPr id="102" name="Rectangle 101"/>
+          <p:cNvSpPr/>
+          <p:nvPr/>
+        </p:nvSpPr>
+        <p:spPr>
+          <a:xfrm>
+            <a:off x="9253728" y="8019288"/>
+            <a:ext cx="2148840" cy="731520"/>
+          </a:xfrm>
+          <a:prstGeom prst="rect">
+            <a:avLst/>
+          </a:prstGeom>
+          <a:solidFill>
+            <a:srgbClr val="EEF1F8"/>
+          </a:solidFill>
+          <a:ln w="9525">
+            <a:solidFill>
+              <a:srgbClr val="D9DFEA"/>
+            </a:solidFill>
+          </a:ln>
+          <a:effectLst/>
+        </p:spPr>
+        <p:style>
+          <a:lnRef idx="1">
+            <a:schemeClr val="accent1"/>
+          </a:lnRef>
+          <a:fillRef idx="3">
+            <a:schemeClr val="accent1"/>
+          </a:fillRef>
+          <a:effectRef idx="2">
+            <a:schemeClr val="accent1"/>
+          </a:effectRef>
+          <a:fontRef idx="minor">
+            <a:schemeClr val="lt1"/>
+          </a:fontRef>
+        </p:style>
+        <p:txBody>
+          <a:bodyPr rtlCol="0" anchor="ctr"/>
+          <a:lstStyle/>
+          <a:p>
+            <a:pPr algn="ctr"/>
+          </a:p>
+        </p:txBody>
+      </p:sp>
+      <p:sp>
+        <p:nvSpPr>
+          <p:cNvPr id="103" name="TextBox 102"/>
+          <p:cNvSpPr txBox="1"/>
+          <p:nvPr/>
+        </p:nvSpPr>
+        <p:spPr>
+          <a:xfrm>
+            <a:off x="9418320" y="8019288"/>
+            <a:ext cx="1874520" cy="731520"/>
+          </a:xfrm>
+          <a:prstGeom prst="rect">
+            <a:avLst/>
+          </a:prstGeom>
+          <a:noFill/>
+        </p:spPr>
+        <p:txBody>
+          <a:bodyPr wrap="square" anchor="ctr" lIns="0" rIns="0" tIns="0" bIns="0">
+            <a:spAutoFit/>
+          </a:bodyPr>
+          <a:lstStyle/>
+          <a:p>
+            <a:pPr algn="l"/>
+            <a:r>
+              <a:rPr sz="1550" b="1" i="0">
+                <a:solidFill>
+                  <a:srgbClr val="132257"/>
+                </a:solidFill>
+                <a:latin typeface="Exo 2 Bold"/>
+                <a:ea typeface="Exo 2 Bold"/>
+                <a:cs typeface="Exo 2 Bold"/>
+              </a:rPr>
+              <a:t>30,000</a:t>
+            </a:r>
+          </a:p>
+        </p:txBody>
+      </p:sp>
+      <p:sp>
+        <p:nvSpPr>
+          <p:cNvPr id="104" name="Rectangle 103"/>
+          <p:cNvSpPr/>
+          <p:nvPr/>
+        </p:nvSpPr>
+        <p:spPr>
+          <a:xfrm>
+            <a:off x="11402568" y="8019288"/>
+            <a:ext cx="6053328" cy="731520"/>
+          </a:xfrm>
+          <a:prstGeom prst="rect">
+            <a:avLst/>
+          </a:prstGeom>
+          <a:solidFill>
+            <a:srgbClr val="EEF1F8"/>
+          </a:solidFill>
+          <a:ln w="9525">
+            <a:solidFill>
+              <a:srgbClr val="D9DFEA"/>
+            </a:solidFill>
+          </a:ln>
+          <a:effectLst/>
+        </p:spPr>
+        <p:style>
+          <a:lnRef idx="1">
+            <a:schemeClr val="accent1"/>
+          </a:lnRef>
+          <a:fillRef idx="3">
+            <a:schemeClr val="accent1"/>
+          </a:fillRef>
+          <a:effectRef idx="2">
+            <a:schemeClr val="accent1"/>
+          </a:effectRef>
+          <a:fontRef idx="minor">
+            <a:schemeClr val="lt1"/>
+          </a:fontRef>
+        </p:style>
+        <p:txBody>
+          <a:bodyPr rtlCol="0" anchor="ctr"/>
+          <a:lstStyle/>
+          <a:p>
+            <a:pPr algn="ctr"/>
+          </a:p>
+        </p:txBody>
+      </p:sp>
+      <p:sp>
+        <p:nvSpPr>
+          <p:cNvPr id="105" name="TextBox 104"/>
+          <p:cNvSpPr txBox="1"/>
+          <p:nvPr/>
+        </p:nvSpPr>
+        <p:spPr>
+          <a:xfrm>
+            <a:off x="11567160" y="8019288"/>
+            <a:ext cx="5779008" cy="731520"/>
+          </a:xfrm>
+          <a:prstGeom prst="rect">
+            <a:avLst/>
+          </a:prstGeom>
+          <a:noFill/>
+        </p:spPr>
+        <p:txBody>
+          <a:bodyPr wrap="square" anchor="ctr" lIns="0" rIns="0" tIns="0" bIns="0">
+            <a:spAutoFit/>
+          </a:bodyPr>
+          <a:lstStyle/>
+          <a:p>
+            <a:pPr algn="l"/>
+            <a:r>
+              <a:rPr sz="1450" b="0" i="0">
+                <a:solidFill>
+                  <a:srgbClr val="1F2A44"/>
+                </a:solidFill>
+                <a:latin typeface="Exo 2"/>
+                <a:ea typeface="Exo 2"/>
+                <a:cs typeface="Exo 2"/>
+              </a:rPr>
+              <a:t>70% of September website visits (see next slides)</a:t>
+            </a:r>
+          </a:p>
+        </p:txBody>
+      </p:sp>
+      <p:sp>
+        <p:nvSpPr>
+          <p:cNvPr id="106" name="Rectangle 105"/>
+          <p:cNvSpPr/>
+          <p:nvPr/>
+        </p:nvSpPr>
+        <p:spPr>
+          <a:xfrm>
+            <a:off x="841248" y="8915400"/>
+            <a:ext cx="16614648" cy="548640"/>
+          </a:xfrm>
+          <a:prstGeom prst="rect">
+            <a:avLst/>
+          </a:prstGeom>
+          <a:solidFill>
+            <a:srgbClr val="EEF1F8"/>
+          </a:solidFill>
+          <a:ln>
+            <a:noFill/>
+          </a:ln>
+          <a:effectLst/>
+        </p:spPr>
+        <p:style>
+          <a:lnRef idx="1">
+            <a:schemeClr val="accent1"/>
+          </a:lnRef>
+          <a:fillRef idx="3">
+            <a:schemeClr val="accent1"/>
+          </a:fillRef>
+          <a:effectRef idx="2">
+            <a:schemeClr val="accent1"/>
+          </a:effectRef>
+          <a:fontRef idx="minor">
+            <a:schemeClr val="lt1"/>
+          </a:fontRef>
+        </p:style>
+        <p:txBody>
+          <a:bodyPr rtlCol="0" anchor="ctr"/>
+          <a:lstStyle/>
+          <a:p>
+            <a:pPr algn="ctr"/>
+          </a:p>
+        </p:txBody>
+      </p:sp>
+      <p:sp>
+        <p:nvSpPr>
+          <p:cNvPr id="107" name="Rectangle 106"/>
+          <p:cNvSpPr/>
+          <p:nvPr/>
+        </p:nvSpPr>
+        <p:spPr>
+          <a:xfrm>
+            <a:off x="841248" y="8915400"/>
+            <a:ext cx="100584" cy="548640"/>
+          </a:xfrm>
+          <a:prstGeom prst="rect">
+            <a:avLst/>
+          </a:prstGeom>
+          <a:solidFill>
+            <a:srgbClr val="D4AF37"/>
+          </a:solidFill>
+          <a:ln>
+            <a:noFill/>
+          </a:ln>
+          <a:effectLst/>
+        </p:spPr>
+        <p:style>
+          <a:lnRef idx="1">
+            <a:schemeClr val="accent1"/>
+          </a:lnRef>
+          <a:fillRef idx="3">
+            <a:schemeClr val="accent1"/>
+          </a:fillRef>
+          <a:effectRef idx="2">
+            <a:schemeClr val="accent1"/>
+          </a:effectRef>
+          <a:fontRef idx="minor">
+            <a:schemeClr val="lt1"/>
+          </a:fontRef>
+        </p:style>
+        <p:txBody>
+          <a:bodyPr rtlCol="0" anchor="ctr"/>
+          <a:lstStyle/>
+          <a:p>
+            <a:pPr algn="ctr"/>
+          </a:p>
+        </p:txBody>
+      </p:sp>
+      <p:sp>
+        <p:nvSpPr>
+          <p:cNvPr id="108" name="TextBox 107"/>
+          <p:cNvSpPr txBox="1"/>
+          <p:nvPr/>
+        </p:nvSpPr>
+        <p:spPr>
+          <a:xfrm>
+            <a:off x="1188720" y="8915400"/>
+            <a:ext cx="16093440" cy="548640"/>
+          </a:xfrm>
+          <a:prstGeom prst="rect">
+            <a:avLst/>
+          </a:prstGeom>
+          <a:noFill/>
+        </p:spPr>
+        <p:txBody>
+          <a:bodyPr wrap="square" anchor="ctr" lIns="0" rIns="0" tIns="0" bIns="0">
+            <a:spAutoFit/>
+          </a:bodyPr>
+          <a:lstStyle/>
+          <a:p>
+            <a:pPr algn="l"/>
+            <a:r>
+              <a:rPr sz="1450" b="1" i="0">
+                <a:solidFill>
+                  <a:srgbClr val="132257"/>
+                </a:solidFill>
+                <a:latin typeface="Exo 2 Bold"/>
+                <a:ea typeface="Exo 2 Bold"/>
+                <a:cs typeface="Exo 2 Bold"/>
+              </a:rPr>
+              <a:t>Spent to date: USD 34,482 </a:t>
+            </a:r>
+            <a:r>
+              <a:rPr sz="1450" b="0" i="0">
+                <a:solidFill>
+                  <a:srgbClr val="1F2A44"/>
+                </a:solidFill>
+                <a:latin typeface="Exo 2"/>
+                <a:ea typeface="Exo 2"/>
+                <a:cs typeface="Exo 2"/>
+              </a:rPr>
+              <a:t>(14 May to 6 Sep, from a USD 80,000 allocated budget), plus USD 30,000 for Google Ads and LinkedIn from Sep to Dec.</a:t>
+            </a:r>
+          </a:p>
+        </p:txBody>
+      </p:sp>
+    </p:spTree>
+  </p:cSld>
+  <p:clrMapOvr>
+    <a:masterClrMapping/>
+  </p:clrMapOvr>
+</p:sld>
+</file>
+
 <file path=ppt/slides/slide2.xml><?xml version="1.0" encoding="utf-8"?>
 <p:sld xmlns:p="http://schemas.openxmlformats.org/presentationml/2006/main" xmlns:a="http://schemas.openxmlformats.org/drawingml/2006/main" xmlns:r="http://schemas.openxmlformats.org/officeDocument/2006/relationships">
   <p:cSld>
@@ -7403,7 +11820,7 @@
                 <a:cs typeface="Exo 2"/>
                 <a:sym typeface="Exo 2"/>
               </a:rPr>
-              <a:t>4</a:t>
+              <a:t>5</a:t>
             </a:r>
           </a:p>
         </p:txBody>
@@ -11071,7 +15488,7 @@
                 <a:cs typeface="Exo 2"/>
                 <a:sym typeface="Exo 2"/>
               </a:rPr>
-              <a:t>5</a:t>
+              <a:t>6</a:t>
             </a:r>
           </a:p>
         </p:txBody>
@@ -16344,7 +20761,7 @@
                 <a:cs typeface="Exo 2"/>
                 <a:sym typeface="Exo 2"/>
               </a:rPr>
-              <a:t>6</a:t>
+              <a:t>7</a:t>
             </a:r>
           </a:p>
         </p:txBody>
@@ -17308,7 +21725,7 @@
                 <a:cs typeface="Exo 2"/>
                 <a:sym typeface="Exo 2"/>
               </a:rPr>
-              <a:t>8</a:t>
+              <a:t>9</a:t>
             </a:r>
           </a:p>
         </p:txBody>
@@ -21261,7 +25678,7 @@
                 <a:cs typeface="Exo 2"/>
                 <a:sym typeface="Exo 2"/>
               </a:rPr>
-              <a:t>7</a:t>
+              <a:t>8</a:t>
             </a:r>
           </a:p>
         </p:txBody>

</xml_diff>